<commit_message>
integrate new training results and write presentation
</commit_message>
<xml_diff>
--- a/reports/current_presentation.pptx
+++ b/reports/current_presentation.pptx
@@ -11175,10 +11175,10 @@
       </p:sp>
       <p:pic>
         <p:nvPicPr>
-          <p:cNvPr id="4" name="Grafik 3">
+          <p:cNvPr id="8" name="Grafik 7">
             <a:extLst>
               <a:ext uri="{FF2B5EF4-FFF2-40B4-BE49-F238E27FC236}">
-                <a16:creationId xmlns:a16="http://schemas.microsoft.com/office/drawing/2014/main" id="{BB0DF998-4034-61FF-1299-13EF83D45C2F}"/>
+                <a16:creationId xmlns:a16="http://schemas.microsoft.com/office/drawing/2014/main" id="{5B7E92F0-C7C1-F628-B9AD-0C9603A5EC36}"/>
               </a:ext>
             </a:extLst>
           </p:cNvPr>
@@ -11188,20 +11188,20 @@
           <p:nvPr/>
         </p:nvPicPr>
         <p:blipFill>
-          <a:blip r:embed="rId3">
+          <a:blip r:embed="rId3" cstate="print">
             <a:extLst>
               <a:ext uri="{28A0092B-C50C-407E-A947-70E740481C1C}">
                 <a14:useLocalDpi xmlns:a14="http://schemas.microsoft.com/office/drawing/2010/main" val="0"/>
               </a:ext>
             </a:extLst>
           </a:blip>
-          <a:srcRect l="1710" r="1710"/>
+          <a:srcRect/>
           <a:stretch/>
         </p:blipFill>
         <p:spPr>
           <a:xfrm>
-            <a:off x="468429" y="1988839"/>
-            <a:ext cx="5449355" cy="2833737"/>
+            <a:off x="6274217" y="1460984"/>
+            <a:ext cx="5486411" cy="4572009"/>
           </a:xfrm>
           <a:prstGeom prst="rect">
             <a:avLst/>
@@ -11210,10 +11210,10 @@
       </p:pic>
       <p:pic>
         <p:nvPicPr>
-          <p:cNvPr id="8" name="Grafik 7">
+          <p:cNvPr id="5" name="Grafik 4">
             <a:extLst>
               <a:ext uri="{FF2B5EF4-FFF2-40B4-BE49-F238E27FC236}">
-                <a16:creationId xmlns:a16="http://schemas.microsoft.com/office/drawing/2014/main" id="{5B7E92F0-C7C1-F628-B9AD-0C9603A5EC36}"/>
+                <a16:creationId xmlns:a16="http://schemas.microsoft.com/office/drawing/2014/main" id="{908D1985-B38D-23EB-1FDF-269858936932}"/>
               </a:ext>
             </a:extLst>
           </p:cNvPr>
@@ -11223,20 +11223,15 @@
           <p:nvPr/>
         </p:nvPicPr>
         <p:blipFill>
-          <a:blip r:embed="rId4" cstate="print">
-            <a:extLst>
-              <a:ext uri="{28A0092B-C50C-407E-A947-70E740481C1C}">
-                <a14:useLocalDpi xmlns:a14="http://schemas.microsoft.com/office/drawing/2010/main" val="0"/>
-              </a:ext>
-            </a:extLst>
-          </a:blip>
-          <a:srcRect/>
-          <a:stretch/>
+          <a:blip r:embed="rId4"/>
+          <a:stretch>
+            <a:fillRect/>
+          </a:stretch>
         </p:blipFill>
         <p:spPr>
           <a:xfrm>
-            <a:off x="6274217" y="1460984"/>
-            <a:ext cx="5486411" cy="4572009"/>
+            <a:off x="291584" y="1908896"/>
+            <a:ext cx="5827066" cy="3040208"/>
           </a:xfrm>
           <a:prstGeom prst="rect">
             <a:avLst/>
@@ -12576,7 +12571,7 @@
         <p:spPr>
           <a:xfrm>
             <a:off x="190291" y="2996951"/>
-            <a:ext cx="4032448" cy="3939540"/>
+            <a:ext cx="4032448" cy="3570208"/>
           </a:xfrm>
           <a:prstGeom prst="rect">
             <a:avLst/>
@@ -12612,7 +12607,7 @@
                 <a:ea typeface="Calibri Light" panose="020F0302020204030204" pitchFamily="34" charset="0"/>
                 <a:cs typeface="Calibri Light" panose="020F0302020204030204" pitchFamily="34" charset="0"/>
               </a:rPr>
-              <a:t>Which content-related genre-discriminative lyrical style patterns (topics, sentiments, formulaic expressions) exist in Anglophone German popular music?</a:t>
+              <a:t>Which lyrical style patterns (topics, sentiments, formulaic expressions) discriminate genres in Anglophone German popular music?</a:t>
             </a:r>
           </a:p>
           <a:p>
@@ -12726,7 +12721,7 @@
         <p:spPr>
           <a:xfrm>
             <a:off x="4311016" y="2996951"/>
-            <a:ext cx="3600400" cy="2616101"/>
+            <a:ext cx="3600400" cy="2339102"/>
           </a:xfrm>
           <a:prstGeom prst="rect">
             <a:avLst/>
@@ -12765,7 +12760,7 @@
                 <a:ea typeface="Calibri Light" panose="020F0302020204030204" pitchFamily="34" charset="0"/>
                 <a:cs typeface="Calibri Light" panose="020F0302020204030204" pitchFamily="34" charset="0"/>
               </a:rPr>
-              <a:t> To what extent do style pattern-based interpretable ML models match a fine-tuned DistilBERT LLM baseline on lyrics-based popular music genre prediction?</a:t>
+              <a:t> To what extent do style-based interpretable ML models match a fine-tuned DistilBERT LLM baseline on lyrics-based music genre prediction?</a:t>
             </a:r>
             <a:endParaRPr lang="en-US" sz="2000" dirty="0">
               <a:latin typeface="Calibri Light" panose="020F0302020204030204" pitchFamily="34" charset="0"/>
@@ -12803,7 +12798,7 @@
             </a:r>
             <a:r>
               <a:rPr lang="de-DE" sz="2000" dirty="0"/>
-              <a:t> 84,3% </a:t>
+              <a:t> 83,3% </a:t>
             </a:r>
             <a:r>
               <a:rPr lang="de-DE" sz="2000" dirty="0" err="1"/>
@@ -12836,7 +12831,7 @@
         <p:spPr>
           <a:xfrm>
             <a:off x="8160229" y="2996951"/>
-            <a:ext cx="3600400" cy="3216265"/>
+            <a:ext cx="3600400" cy="2908489"/>
           </a:xfrm>
           <a:prstGeom prst="rect">
             <a:avLst/>
@@ -12877,13 +12872,6 @@
           </a:p>
           <a:p>
             <a:endParaRPr lang="en-US" sz="1100" dirty="0">
-              <a:latin typeface="Calibri Light" panose="020F0302020204030204" pitchFamily="34" charset="0"/>
-              <a:ea typeface="Calibri Light" panose="020F0302020204030204" pitchFamily="34" charset="0"/>
-              <a:cs typeface="Calibri Light" panose="020F0302020204030204" pitchFamily="34" charset="0"/>
-            </a:endParaRPr>
-          </a:p>
-          <a:p>
-            <a:endParaRPr lang="de-DE" sz="2000" dirty="0">
               <a:latin typeface="Calibri Light" panose="020F0302020204030204" pitchFamily="34" charset="0"/>
               <a:ea typeface="Calibri Light" panose="020F0302020204030204" pitchFamily="34" charset="0"/>
               <a:cs typeface="Calibri Light" panose="020F0302020204030204" pitchFamily="34" charset="0"/>
@@ -13441,7 +13429,15 @@
                 <a:ea typeface="Calibri Light" panose="020F0302020204030204" pitchFamily="34" charset="0"/>
                 <a:cs typeface="Calibri Light" panose="020F0302020204030204" pitchFamily="34" charset="0"/>
               </a:rPr>
-              <a:t>Melancholic</a:t>
+              <a:t>Hich prevalence of negatively </a:t>
+            </a:r>
+            <a:r>
+              <a:rPr lang="en-US" sz="2000" dirty="0" err="1">
+                <a:latin typeface="+mj-lt"/>
+                <a:ea typeface="Calibri Light" panose="020F0302020204030204" pitchFamily="34" charset="0"/>
+                <a:cs typeface="Calibri Light" panose="020F0302020204030204" pitchFamily="34" charset="0"/>
+              </a:rPr>
+              <a:t>valenced</a:t>
             </a:r>
             <a:r>
               <a:rPr lang="en-US" sz="2000" b="0" dirty="0">
@@ -13457,7 +13453,7 @@
                 <a:ea typeface="Calibri Light" panose="020F0302020204030204" pitchFamily="34" charset="0"/>
                 <a:cs typeface="Calibri Light" panose="020F0302020204030204" pitchFamily="34" charset="0"/>
               </a:rPr>
-              <a:t>topics, sentiment, formulaic expression large prevalence in the corpus</a:t>
+              <a:t>topics, sentiment, formulaic expressions in the corpus</a:t>
             </a:r>
             <a:r>
               <a:rPr lang="en-US" sz="2000" b="0" baseline="30000" dirty="0">
@@ -13465,7 +13461,7 @@
                 <a:ea typeface="Calibri Light" panose="020F0302020204030204" pitchFamily="34" charset="0"/>
                 <a:cs typeface="Calibri Light" panose="020F0302020204030204" pitchFamily="34" charset="0"/>
               </a:rPr>
-              <a:t>2</a:t>
+              <a:t>2,3</a:t>
             </a:r>
             <a:r>
               <a:rPr lang="en-US" sz="2000" b="0" dirty="0">
@@ -13521,7 +13517,7 @@
             </a:r>
             <a:r>
               <a:rPr lang="de-DE" dirty="0"/>
-              <a:t> (2018)   </a:t>
+              <a:t> (2018)  </a:t>
             </a:r>
             <a:r>
               <a:rPr lang="de-DE" baseline="30000" dirty="0"/>
@@ -13529,7 +13525,7 @@
             </a:r>
             <a:r>
               <a:rPr lang="de-DE" dirty="0"/>
-              <a:t>Fell &amp; Sporleder (2014)   </a:t>
+              <a:t>Brandl et al. (2019)   </a:t>
             </a:r>
             <a:r>
               <a:rPr lang="de-DE" baseline="30000" dirty="0"/>
@@ -13537,11 +13533,19 @@
             </a:r>
             <a:r>
               <a:rPr lang="de-DE" dirty="0"/>
-              <a:t>Rudin (2019)   </a:t>
+              <a:t>Fell &amp; Sporleder (2014)   </a:t>
             </a:r>
             <a:r>
               <a:rPr lang="de-DE" baseline="30000" dirty="0"/>
               <a:t>5 </a:t>
+            </a:r>
+            <a:r>
+              <a:rPr lang="de-DE" dirty="0"/>
+              <a:t>Rudin (2019)   </a:t>
+            </a:r>
+            <a:r>
+              <a:rPr lang="de-DE" baseline="30000" dirty="0"/>
+              <a:t>6 </a:t>
             </a:r>
             <a:r>
               <a:rPr lang="de-DE" dirty="0" err="1"/>
@@ -14217,7 +14221,7 @@
                 <a:ea typeface="Calibri Light" panose="020F0302020204030204" pitchFamily="34" charset="0"/>
                 <a:cs typeface="Calibri Light" panose="020F0302020204030204" pitchFamily="34" charset="0"/>
               </a:rPr>
-              <a:t>3</a:t>
+              <a:t>4</a:t>
             </a:r>
             <a:r>
               <a:rPr lang="en-US" sz="2000" b="0" dirty="0">
@@ -14551,7 +14555,7 @@
                 <a:ea typeface="Calibri Light" panose="020F0302020204030204" pitchFamily="34" charset="0"/>
                 <a:cs typeface="Calibri Light" panose="020F0302020204030204" pitchFamily="34" charset="0"/>
               </a:rPr>
-              <a:t>4,5</a:t>
+              <a:t>5,6</a:t>
             </a:r>
           </a:p>
         </p:txBody>
@@ -18814,7 +18818,7 @@
                 <a:ea typeface="Calibri Light" panose="020F0302020204030204" pitchFamily="34" charset="0"/>
                 <a:cs typeface="Calibri Light" panose="020F0302020204030204" pitchFamily="34" charset="0"/>
               </a:rPr>
-              <a:t>content-related genre-discriminative lyrical style patterns </a:t>
+              <a:t>lyrical style patterns </a:t>
             </a:r>
             <a:r>
               <a:rPr lang="en-US" sz="2400" b="0" dirty="0">
@@ -18822,7 +18826,23 @@
                 <a:ea typeface="Calibri Light" panose="020F0302020204030204" pitchFamily="34" charset="0"/>
                 <a:cs typeface="Calibri Light" panose="020F0302020204030204" pitchFamily="34" charset="0"/>
               </a:rPr>
-              <a:t>(topics, sentiments, formulaic expressions) exist in Anglophone German popular music?</a:t>
+              <a:t>(topics, sentiments, formulaic expressions) </a:t>
+            </a:r>
+            <a:r>
+              <a:rPr lang="en-US" sz="2400" dirty="0">
+                <a:latin typeface="+mj-lt"/>
+                <a:ea typeface="Calibri Light" panose="020F0302020204030204" pitchFamily="34" charset="0"/>
+                <a:cs typeface="Calibri Light" panose="020F0302020204030204" pitchFamily="34" charset="0"/>
+              </a:rPr>
+              <a:t>discriminate genres </a:t>
+            </a:r>
+            <a:r>
+              <a:rPr lang="en-US" sz="2400" b="0" dirty="0">
+                <a:latin typeface="Calibri Light" panose="020F0302020204030204" pitchFamily="34" charset="0"/>
+                <a:ea typeface="Calibri Light" panose="020F0302020204030204" pitchFamily="34" charset="0"/>
+                <a:cs typeface="Calibri Light" panose="020F0302020204030204" pitchFamily="34" charset="0"/>
+              </a:rPr>
+              <a:t>in Anglophone German popular music?</a:t>
             </a:r>
           </a:p>
           <a:p>
@@ -19236,7 +19256,7 @@
                 <a:ea typeface="Calibri Light" panose="020F0302020204030204" pitchFamily="34" charset="0"/>
                 <a:cs typeface="Calibri Light" panose="020F0302020204030204" pitchFamily="34" charset="0"/>
               </a:rPr>
-              <a:t>do style pattern-based </a:t>
+              <a:t>do style-based </a:t>
             </a:r>
             <a:r>
               <a:rPr lang="en-US" sz="2400" dirty="0">
@@ -19260,7 +19280,7 @@
                 <a:ea typeface="Calibri Light" panose="020F0302020204030204" pitchFamily="34" charset="0"/>
                 <a:cs typeface="Calibri Light" panose="020F0302020204030204" pitchFamily="34" charset="0"/>
               </a:rPr>
-              <a:t>on lyrics-based popular music genre prediction?</a:t>
+              <a:t>on lyrics-based music genre prediction?</a:t>
             </a:r>
             <a:endParaRPr lang="de-DE" sz="2400" dirty="0">
               <a:latin typeface="Calibri Light" panose="020F0302020204030204" pitchFamily="34" charset="0"/>

</xml_diff>

<commit_message>
finish paper after presentation in colloquium
</commit_message>
<xml_diff>
--- a/reports/current_presentation.pptx
+++ b/reports/current_presentation.pptx
@@ -249,7 +249,7 @@
           <a:p>
             <a:fld id="{AD399400-5849-4723-8898-46BF5BDB3735}" type="datetimeFigureOut">
               <a:rPr lang="en-US" smtClean="0"/>
-              <a:t>4/22/2026</a:t>
+              <a:t>4/23/2026</a:t>
             </a:fld>
             <a:endParaRPr lang="en-US"/>
           </a:p>
@@ -426,7 +426,7 @@
           <a:p>
             <a:fld id="{EC90C3A3-A726-420C-8DD1-C905CEB9E511}" type="datetimeFigureOut">
               <a:rPr lang="de-DE" smtClean="0"/>
-              <a:t>22.04.2026</a:t>
+              <a:t>23.04.2026</a:t>
             </a:fld>
             <a:endParaRPr lang="de-DE"/>
           </a:p>
@@ -2610,32 +2610,12 @@
           <a:lstStyle/>
           <a:p>
             <a:r>
+              <a:rPr lang="en-US" dirty="0" err="1"/>
+              <a:t>MediaControl</a:t>
+            </a:r>
+            <a:r>
               <a:rPr lang="en-US" dirty="0"/>
-              <a:t>Why </a:t>
-            </a:r>
-            <a:r>
-              <a:rPr lang="en-US" dirty="0" err="1"/>
-              <a:t>Musicbrainz</a:t>
-            </a:r>
-            <a:r>
-              <a:rPr lang="en-US" dirty="0"/>
-              <a:t>: </a:t>
-            </a:r>
-          </a:p>
-          <a:p>
-            <a:r>
-              <a:rPr lang="en-US" dirty="0"/>
-              <a:t>many genres </a:t>
-            </a:r>
-          </a:p>
-          <a:p>
-            <a:r>
-              <a:rPr lang="en-US" dirty="0" err="1"/>
-              <a:t>Democartic</a:t>
-            </a:r>
-            <a:r>
-              <a:rPr lang="en-US" dirty="0"/>
-              <a:t> voting</a:t>
+              <a:t> GERMAN</a:t>
             </a:r>
           </a:p>
         </p:txBody>
@@ -3102,7 +3082,7 @@
           <a:p>
             <a:fld id="{33690E58-811E-483E-B740-9C8996AC2956}" type="datetime1">
               <a:rPr lang="de-DE" smtClean="0"/>
-              <a:t>22.04.2026</a:t>
+              <a:t>23.04.2026</a:t>
             </a:fld>
             <a:endParaRPr lang="de-DE"/>
           </a:p>
@@ -3270,7 +3250,7 @@
           <a:p>
             <a:fld id="{C6B6E9B0-EE0C-4B3A-BB69-6CCF46E83C5E}" type="datetime1">
               <a:rPr lang="de-DE" smtClean="0"/>
-              <a:t>22.04.2026</a:t>
+              <a:t>23.04.2026</a:t>
             </a:fld>
             <a:endParaRPr lang="de-DE"/>
           </a:p>
@@ -3448,7 +3428,7 @@
           <a:p>
             <a:fld id="{D8DEB393-392B-487F-B733-C7A016927E97}" type="datetime1">
               <a:rPr lang="de-DE" smtClean="0"/>
-              <a:t>22.04.2026</a:t>
+              <a:t>23.04.2026</a:t>
             </a:fld>
             <a:endParaRPr lang="de-DE"/>
           </a:p>
@@ -3616,7 +3596,7 @@
           <a:p>
             <a:fld id="{BD26C20F-C26F-410B-813C-64F16A8B9B47}" type="datetime1">
               <a:rPr lang="de-DE" smtClean="0"/>
-              <a:t>22.04.2026</a:t>
+              <a:t>23.04.2026</a:t>
             </a:fld>
             <a:endParaRPr lang="de-DE"/>
           </a:p>
@@ -3767,7 +3747,7 @@
           <a:p>
             <a:fld id="{6B9F3A22-DAB4-427F-83FC-348F41F95BAF}" type="datetime1">
               <a:rPr lang="de-DE" smtClean="0"/>
-              <a:t>22.04.2026</a:t>
+              <a:t>23.04.2026</a:t>
             </a:fld>
             <a:endParaRPr lang="de-DE"/>
           </a:p>
@@ -4270,7 +4250,7 @@
           <a:p>
             <a:fld id="{44845DB8-E77B-4FEE-BCA4-D5E2324673A7}" type="datetime1">
               <a:rPr lang="de-DE" smtClean="0"/>
-              <a:t>22.04.2026</a:t>
+              <a:t>23.04.2026</a:t>
             </a:fld>
             <a:endParaRPr lang="de-DE" dirty="0"/>
           </a:p>
@@ -5700,7 +5680,7 @@
           <a:p>
             <a:fld id="{F5AB78C5-963A-4C35-9FD5-A0A0A78C11CD}" type="datetime1">
               <a:rPr lang="de-DE" smtClean="0"/>
-              <a:t>22.04.2026</a:t>
+              <a:t>23.04.2026</a:t>
             </a:fld>
             <a:endParaRPr lang="de-DE"/>
           </a:p>
@@ -5985,7 +5965,7 @@
           <a:p>
             <a:fld id="{C00B4BFD-FCB8-42C5-B688-F88CFAF184EB}" type="datetime1">
               <a:rPr lang="de-DE" smtClean="0"/>
-              <a:t>22.04.2026</a:t>
+              <a:t>23.04.2026</a:t>
             </a:fld>
             <a:endParaRPr lang="de-DE"/>
           </a:p>
@@ -6404,7 +6384,7 @@
           <a:p>
             <a:fld id="{A5F527D4-BA55-4BD4-9E93-88EF3ED4CE3A}" type="datetime1">
               <a:rPr lang="de-DE" smtClean="0"/>
-              <a:t>22.04.2026</a:t>
+              <a:t>23.04.2026</a:t>
             </a:fld>
             <a:endParaRPr lang="de-DE"/>
           </a:p>
@@ -6521,7 +6501,7 @@
           <a:p>
             <a:fld id="{3B3D687F-B0A0-4C9D-B12F-6DD442A29E20}" type="datetime1">
               <a:rPr lang="de-DE" smtClean="0"/>
-              <a:t>22.04.2026</a:t>
+              <a:t>23.04.2026</a:t>
             </a:fld>
             <a:endParaRPr lang="de-DE"/>
           </a:p>
@@ -6616,7 +6596,7 @@
           <a:p>
             <a:fld id="{9DDF7125-8B58-41AD-BA18-3DA1625618A0}" type="datetime1">
               <a:rPr lang="de-DE" smtClean="0"/>
-              <a:t>22.04.2026</a:t>
+              <a:t>23.04.2026</a:t>
             </a:fld>
             <a:endParaRPr lang="de-DE"/>
           </a:p>
@@ -6891,7 +6871,7 @@
           <a:p>
             <a:fld id="{B73404B6-D29A-4D50-A260-F579AF5882EB}" type="datetime1">
               <a:rPr lang="de-DE" smtClean="0"/>
-              <a:t>22.04.2026</a:t>
+              <a:t>23.04.2026</a:t>
             </a:fld>
             <a:endParaRPr lang="de-DE"/>
           </a:p>
@@ -7146,7 +7126,7 @@
           <a:p>
             <a:fld id="{371051C0-CE15-4F99-AEFA-0D2DE64965B9}" type="datetime1">
               <a:rPr lang="de-DE" smtClean="0"/>
-              <a:t>22.04.2026</a:t>
+              <a:t>23.04.2026</a:t>
             </a:fld>
             <a:endParaRPr lang="de-DE"/>
           </a:p>
@@ -7357,7 +7337,7 @@
           <a:p>
             <a:fld id="{9951ED2B-C080-4D4C-96E4-F13916094505}" type="datetime1">
               <a:rPr lang="de-DE" smtClean="0"/>
-              <a:t>22.04.2026</a:t>
+              <a:t>23.04.2026</a:t>
             </a:fld>
             <a:endParaRPr lang="de-DE"/>
           </a:p>
@@ -8215,7 +8195,15 @@
             </a:r>
             <a:r>
               <a:rPr lang="de-DE" dirty="0"/>
-              <a:t>‘ Words </a:t>
+              <a:t>‘ n-</a:t>
+            </a:r>
+            <a:r>
+              <a:rPr lang="de-DE" dirty="0" err="1"/>
+              <a:t>grams</a:t>
+            </a:r>
+            <a:r>
+              <a:rPr lang="de-DE" dirty="0"/>
+              <a:t> </a:t>
             </a:r>
             <a:r>
               <a:rPr lang="de-DE" dirty="0" err="1"/>
@@ -10779,16 +10767,67 @@
           <a:bodyPr/>
           <a:lstStyle/>
           <a:p>
-            <a:endParaRPr lang="de-DE"/>
+            <a:endParaRPr lang="de-DE" dirty="0"/>
+          </a:p>
+        </p:txBody>
+      </p:sp>
+      <p:sp>
+        <p:nvSpPr>
+          <p:cNvPr id="4" name="Textfeld 3">
+            <a:extLst>
+              <a:ext uri="{FF2B5EF4-FFF2-40B4-BE49-F238E27FC236}">
+                <a16:creationId xmlns:a16="http://schemas.microsoft.com/office/drawing/2014/main" id="{F6F658EC-53DB-E331-5B44-9DAD56FEC446}"/>
+              </a:ext>
+            </a:extLst>
+          </p:cNvPr>
+          <p:cNvSpPr txBox="1"/>
+          <p:nvPr/>
+        </p:nvSpPr>
+        <p:spPr>
+          <a:xfrm>
+            <a:off x="218952" y="1020429"/>
+            <a:ext cx="8435883" cy="1446550"/>
+          </a:xfrm>
+          <a:prstGeom prst="rect">
+            <a:avLst/>
+          </a:prstGeom>
+          <a:noFill/>
+        </p:spPr>
+        <p:txBody>
+          <a:bodyPr wrap="square" rtlCol="0">
+            <a:spAutoFit/>
+          </a:bodyPr>
+          <a:lstStyle/>
+          <a:p>
+            <a:r>
+              <a:rPr lang="en-US" sz="2200" b="1" dirty="0"/>
+              <a:t>12 Topics, 8 Sentiments, 15 Expression Types</a:t>
+            </a:r>
+          </a:p>
+          <a:p>
+            <a:endParaRPr lang="en-US" sz="2200" b="1" dirty="0"/>
+          </a:p>
+          <a:p>
+            <a:r>
+              <a:rPr lang="en-US" sz="2200" dirty="0"/>
+              <a:t>Example Latent Type Interpretations:</a:t>
+            </a:r>
+          </a:p>
+          <a:p>
+            <a:pPr marL="285750" indent="-285750">
+              <a:buFontTx/>
+              <a:buChar char="-"/>
+            </a:pPr>
+            <a:endParaRPr lang="en-US" sz="2200" dirty="0"/>
           </a:p>
         </p:txBody>
       </p:sp>
       <p:pic>
         <p:nvPicPr>
-          <p:cNvPr id="3" name="Grafik 2">
+          <p:cNvPr id="8" name="Grafik 7">
             <a:extLst>
               <a:ext uri="{FF2B5EF4-FFF2-40B4-BE49-F238E27FC236}">
-                <a16:creationId xmlns:a16="http://schemas.microsoft.com/office/drawing/2014/main" id="{B7994F49-E120-0C71-6BDB-B53E33BC5CE0}"/>
+                <a16:creationId xmlns:a16="http://schemas.microsoft.com/office/drawing/2014/main" id="{2D6AC4BF-C420-B1E4-049D-7E3B79D3E1D2}"/>
               </a:ext>
             </a:extLst>
           </p:cNvPr>
@@ -10798,69 +10837,21 @@
           <p:nvPr/>
         </p:nvPicPr>
         <p:blipFill>
-          <a:blip r:embed="rId3">
-            <a:extLst>
-              <a:ext uri="{28A0092B-C50C-407E-A947-70E740481C1C}">
-                <a14:useLocalDpi xmlns:a14="http://schemas.microsoft.com/office/drawing/2010/main" val="0"/>
-              </a:ext>
-            </a:extLst>
-          </a:blip>
-          <a:srcRect/>
-          <a:stretch/>
+          <a:blip r:embed="rId3"/>
+          <a:stretch>
+            <a:fillRect/>
+          </a:stretch>
         </p:blipFill>
         <p:spPr>
           <a:xfrm>
-            <a:off x="468429" y="2204864"/>
-            <a:ext cx="11201244" cy="3024336"/>
+            <a:off x="191344" y="2159606"/>
+            <a:ext cx="12000656" cy="3322006"/>
           </a:xfrm>
           <a:prstGeom prst="rect">
             <a:avLst/>
           </a:prstGeom>
         </p:spPr>
       </p:pic>
-      <p:sp>
-        <p:nvSpPr>
-          <p:cNvPr id="4" name="Textfeld 3">
-            <a:extLst>
-              <a:ext uri="{FF2B5EF4-FFF2-40B4-BE49-F238E27FC236}">
-                <a16:creationId xmlns:a16="http://schemas.microsoft.com/office/drawing/2014/main" id="{F6F658EC-53DB-E331-5B44-9DAD56FEC446}"/>
-              </a:ext>
-            </a:extLst>
-          </p:cNvPr>
-          <p:cNvSpPr txBox="1"/>
-          <p:nvPr/>
-        </p:nvSpPr>
-        <p:spPr>
-          <a:xfrm>
-            <a:off x="468429" y="1564068"/>
-            <a:ext cx="4978350" cy="769441"/>
-          </a:xfrm>
-          <a:prstGeom prst="rect">
-            <a:avLst/>
-          </a:prstGeom>
-          <a:noFill/>
-        </p:spPr>
-        <p:txBody>
-          <a:bodyPr wrap="square" rtlCol="0">
-            <a:spAutoFit/>
-          </a:bodyPr>
-          <a:lstStyle/>
-          <a:p>
-            <a:r>
-              <a:rPr lang="en-US" sz="2200" b="1" dirty="0"/>
-              <a:t>Example Latent Type Interpretations</a:t>
-            </a:r>
-            <a:endParaRPr lang="en-US" sz="2200" dirty="0"/>
-          </a:p>
-          <a:p>
-            <a:pPr marL="285750" indent="-285750">
-              <a:buFontTx/>
-              <a:buChar char="-"/>
-            </a:pPr>
-            <a:endParaRPr lang="en-US" sz="2200" dirty="0"/>
-          </a:p>
-        </p:txBody>
-      </p:sp>
     </p:spTree>
     <p:extLst>
       <p:ext uri="{BB962C8B-B14F-4D97-AF65-F5344CB8AC3E}">
@@ -10973,10 +10964,10 @@
       </p:sp>
       <p:pic>
         <p:nvPicPr>
-          <p:cNvPr id="7" name="Grafik 6">
+          <p:cNvPr id="9" name="Grafik 8">
             <a:extLst>
               <a:ext uri="{FF2B5EF4-FFF2-40B4-BE49-F238E27FC236}">
-                <a16:creationId xmlns:a16="http://schemas.microsoft.com/office/drawing/2014/main" id="{4D3818D1-5ED3-0F13-3546-0931CBE2142A}"/>
+                <a16:creationId xmlns:a16="http://schemas.microsoft.com/office/drawing/2014/main" id="{4A9EB02D-2FE2-E3A0-763C-672BB4DC7B34}"/>
               </a:ext>
             </a:extLst>
           </p:cNvPr>
@@ -10998,8 +10989,8 @@
         </p:blipFill>
         <p:spPr>
           <a:xfrm>
-            <a:off x="4175789" y="1959454"/>
-            <a:ext cx="3936434" cy="3608398"/>
+            <a:off x="-25446" y="1988840"/>
+            <a:ext cx="3936434" cy="3608397"/>
           </a:xfrm>
           <a:prstGeom prst="rect">
             <a:avLst/>
@@ -11008,10 +10999,10 @@
       </p:pic>
       <p:pic>
         <p:nvPicPr>
-          <p:cNvPr id="9" name="Grafik 8">
+          <p:cNvPr id="7" name="Grafik 6">
             <a:extLst>
               <a:ext uri="{FF2B5EF4-FFF2-40B4-BE49-F238E27FC236}">
-                <a16:creationId xmlns:a16="http://schemas.microsoft.com/office/drawing/2014/main" id="{4A9EB02D-2FE2-E3A0-763C-672BB4DC7B34}"/>
+                <a16:creationId xmlns:a16="http://schemas.microsoft.com/office/drawing/2014/main" id="{4D3818D1-5ED3-0F13-3546-0931CBE2142A}"/>
               </a:ext>
             </a:extLst>
           </p:cNvPr>
@@ -11033,8 +11024,8 @@
         </p:blipFill>
         <p:spPr>
           <a:xfrm>
-            <a:off x="239355" y="1954518"/>
-            <a:ext cx="3936434" cy="3608398"/>
+            <a:off x="3829575" y="2044700"/>
+            <a:ext cx="3936434" cy="3608397"/>
           </a:xfrm>
           <a:prstGeom prst="rect">
             <a:avLst/>
@@ -11068,8 +11059,8 @@
         </p:blipFill>
         <p:spPr>
           <a:xfrm>
-            <a:off x="8112223" y="1964390"/>
-            <a:ext cx="3936434" cy="3608398"/>
+            <a:off x="7608168" y="1572219"/>
+            <a:ext cx="4472281" cy="4099590"/>
           </a:xfrm>
           <a:prstGeom prst="rect">
             <a:avLst/>
@@ -11112,6 +11103,36 @@
           <a:chExt cx="0" cy="0"/>
         </a:xfrm>
       </p:grpSpPr>
+      <p:pic>
+        <p:nvPicPr>
+          <p:cNvPr id="9" name="Grafik 8">
+            <a:extLst>
+              <a:ext uri="{FF2B5EF4-FFF2-40B4-BE49-F238E27FC236}">
+                <a16:creationId xmlns:a16="http://schemas.microsoft.com/office/drawing/2014/main" id="{30488A62-FDCF-C185-A214-BBA26A9D5349}"/>
+              </a:ext>
+            </a:extLst>
+          </p:cNvPr>
+          <p:cNvPicPr>
+            <a:picLocks noChangeAspect="1"/>
+          </p:cNvPicPr>
+          <p:nvPr/>
+        </p:nvPicPr>
+        <p:blipFill>
+          <a:blip r:embed="rId3"/>
+          <a:stretch>
+            <a:fillRect/>
+          </a:stretch>
+        </p:blipFill>
+        <p:spPr>
+          <a:xfrm>
+            <a:off x="147801" y="1933561"/>
+            <a:ext cx="5927306" cy="3038683"/>
+          </a:xfrm>
+          <a:prstGeom prst="rect">
+            <a:avLst/>
+          </a:prstGeom>
+        </p:spPr>
+      </p:pic>
       <p:sp>
         <p:nvSpPr>
           <p:cNvPr id="2" name="Titel 1">
@@ -11188,7 +11209,7 @@
           <p:nvPr/>
         </p:nvPicPr>
         <p:blipFill>
-          <a:blip r:embed="rId3" cstate="print">
+          <a:blip r:embed="rId4" cstate="print">
             <a:extLst>
               <a:ext uri="{28A0092B-C50C-407E-A947-70E740481C1C}">
                 <a14:useLocalDpi xmlns:a14="http://schemas.microsoft.com/office/drawing/2010/main" val="0"/>
@@ -11208,36 +11229,267 @@
           </a:prstGeom>
         </p:spPr>
       </p:pic>
-      <p:pic>
-        <p:nvPicPr>
-          <p:cNvPr id="5" name="Grafik 4">
+      <p:sp>
+        <p:nvSpPr>
+          <p:cNvPr id="7" name="Textfeld 6">
             <a:extLst>
               <a:ext uri="{FF2B5EF4-FFF2-40B4-BE49-F238E27FC236}">
-                <a16:creationId xmlns:a16="http://schemas.microsoft.com/office/drawing/2014/main" id="{908D1985-B38D-23EB-1FDF-269858936932}"/>
+                <a16:creationId xmlns:a16="http://schemas.microsoft.com/office/drawing/2014/main" id="{47C45EC1-B586-FBD7-8031-9D5BF5DEE4C5}"/>
               </a:ext>
             </a:extLst>
           </p:cNvPr>
-          <p:cNvPicPr>
-            <a:picLocks noChangeAspect="1"/>
-          </p:cNvPicPr>
+          <p:cNvSpPr txBox="1"/>
           <p:nvPr/>
-        </p:nvPicPr>
-        <p:blipFill>
-          <a:blip r:embed="rId4"/>
-          <a:stretch>
-            <a:fillRect/>
-          </a:stretch>
-        </p:blipFill>
+        </p:nvSpPr>
         <p:spPr>
           <a:xfrm>
-            <a:off x="291584" y="1908896"/>
-            <a:ext cx="5827066" cy="3040208"/>
+            <a:off x="2869784" y="4926117"/>
+            <a:ext cx="3248866" cy="369332"/>
           </a:xfrm>
           <a:prstGeom prst="rect">
             <a:avLst/>
           </a:prstGeom>
+          <a:noFill/>
         </p:spPr>
-      </p:pic>
+        <p:txBody>
+          <a:bodyPr wrap="square">
+            <a:spAutoFit/>
+          </a:bodyPr>
+          <a:lstStyle/>
+          <a:p>
+            <a:r>
+              <a:rPr lang="de-DE" sz="1800" dirty="0">
+                <a:solidFill>
+                  <a:srgbClr val="C40D20"/>
+                </a:solidFill>
+              </a:rPr>
+              <a:t>83,2% </a:t>
+            </a:r>
+            <a:r>
+              <a:rPr lang="de-DE" sz="1800" dirty="0" err="1">
+                <a:solidFill>
+                  <a:srgbClr val="C40D20"/>
+                </a:solidFill>
+              </a:rPr>
+              <a:t>of</a:t>
+            </a:r>
+            <a:r>
+              <a:rPr lang="de-DE" sz="1800" dirty="0">
+                <a:solidFill>
+                  <a:srgbClr val="C40D20"/>
+                </a:solidFill>
+              </a:rPr>
+              <a:t> DistilBERT LLM </a:t>
+            </a:r>
+            <a:r>
+              <a:rPr lang="de-DE" sz="1800" dirty="0" err="1">
+                <a:solidFill>
+                  <a:srgbClr val="C40D20"/>
+                </a:solidFill>
+              </a:rPr>
+              <a:t>baseline</a:t>
+            </a:r>
+            <a:endParaRPr lang="en-US" dirty="0">
+              <a:solidFill>
+                <a:srgbClr val="C40D20"/>
+              </a:solidFill>
+            </a:endParaRPr>
+          </a:p>
+        </p:txBody>
+      </p:sp>
+      <p:sp>
+        <p:nvSpPr>
+          <p:cNvPr id="10" name="Rechteck 9">
+            <a:extLst>
+              <a:ext uri="{FF2B5EF4-FFF2-40B4-BE49-F238E27FC236}">
+                <a16:creationId xmlns:a16="http://schemas.microsoft.com/office/drawing/2014/main" id="{864C058B-7E90-C504-931A-01D80CD2B4CF}"/>
+              </a:ext>
+            </a:extLst>
+          </p:cNvPr>
+          <p:cNvSpPr/>
+          <p:nvPr/>
+        </p:nvSpPr>
+        <p:spPr>
+          <a:xfrm>
+            <a:off x="5447928" y="2700816"/>
+            <a:ext cx="557536" cy="224128"/>
+          </a:xfrm>
+          <a:prstGeom prst="rect">
+            <a:avLst/>
+          </a:prstGeom>
+          <a:noFill/>
+          <a:ln w="19050">
+            <a:solidFill>
+              <a:srgbClr val="C40D20"/>
+            </a:solidFill>
+          </a:ln>
+        </p:spPr>
+        <p:style>
+          <a:lnRef idx="2">
+            <a:schemeClr val="accent1">
+              <a:shade val="50000"/>
+            </a:schemeClr>
+          </a:lnRef>
+          <a:fillRef idx="1">
+            <a:schemeClr val="accent1"/>
+          </a:fillRef>
+          <a:effectRef idx="0">
+            <a:schemeClr val="accent1"/>
+          </a:effectRef>
+          <a:fontRef idx="minor">
+            <a:schemeClr val="lt1"/>
+          </a:fontRef>
+        </p:style>
+        <p:txBody>
+          <a:bodyPr rtlCol="0" anchor="ctr"/>
+          <a:lstStyle/>
+          <a:p>
+            <a:pPr algn="ctr"/>
+            <a:endParaRPr lang="en-US"/>
+          </a:p>
+        </p:txBody>
+      </p:sp>
+      <p:sp>
+        <p:nvSpPr>
+          <p:cNvPr id="11" name="Rechteck 10">
+            <a:extLst>
+              <a:ext uri="{FF2B5EF4-FFF2-40B4-BE49-F238E27FC236}">
+                <a16:creationId xmlns:a16="http://schemas.microsoft.com/office/drawing/2014/main" id="{5F4C70C0-4AE7-555D-B1D0-97D713EAB59A}"/>
+              </a:ext>
+            </a:extLst>
+          </p:cNvPr>
+          <p:cNvSpPr/>
+          <p:nvPr/>
+        </p:nvSpPr>
+        <p:spPr>
+          <a:xfrm>
+            <a:off x="5447928" y="4602912"/>
+            <a:ext cx="557536" cy="229042"/>
+          </a:xfrm>
+          <a:prstGeom prst="rect">
+            <a:avLst/>
+          </a:prstGeom>
+          <a:noFill/>
+          <a:ln w="19050">
+            <a:solidFill>
+              <a:srgbClr val="C40D20"/>
+            </a:solidFill>
+          </a:ln>
+        </p:spPr>
+        <p:style>
+          <a:lnRef idx="2">
+            <a:schemeClr val="accent1">
+              <a:shade val="50000"/>
+            </a:schemeClr>
+          </a:lnRef>
+          <a:fillRef idx="1">
+            <a:schemeClr val="accent1"/>
+          </a:fillRef>
+          <a:effectRef idx="0">
+            <a:schemeClr val="accent1"/>
+          </a:effectRef>
+          <a:fontRef idx="minor">
+            <a:schemeClr val="lt1"/>
+          </a:fontRef>
+        </p:style>
+        <p:txBody>
+          <a:bodyPr rtlCol="0" anchor="ctr"/>
+          <a:lstStyle/>
+          <a:p>
+            <a:pPr algn="ctr"/>
+            <a:endParaRPr lang="en-US"/>
+          </a:p>
+        </p:txBody>
+      </p:sp>
+      <p:sp>
+        <p:nvSpPr>
+          <p:cNvPr id="3" name="Rechteck 2">
+            <a:extLst>
+              <a:ext uri="{FF2B5EF4-FFF2-40B4-BE49-F238E27FC236}">
+                <a16:creationId xmlns:a16="http://schemas.microsoft.com/office/drawing/2014/main" id="{F9032D97-D61E-922A-967A-A163F6A3FDA0}"/>
+              </a:ext>
+            </a:extLst>
+          </p:cNvPr>
+          <p:cNvSpPr/>
+          <p:nvPr/>
+        </p:nvSpPr>
+        <p:spPr>
+          <a:xfrm>
+            <a:off x="6274217" y="1460984"/>
+            <a:ext cx="3505742" cy="792088"/>
+          </a:xfrm>
+          <a:prstGeom prst="rect">
+            <a:avLst/>
+          </a:prstGeom>
+          <a:solidFill>
+            <a:schemeClr val="bg1"/>
+          </a:solidFill>
+          <a:ln w="19050">
+            <a:solidFill>
+              <a:schemeClr val="bg1"/>
+            </a:solidFill>
+          </a:ln>
+        </p:spPr>
+        <p:style>
+          <a:lnRef idx="2">
+            <a:schemeClr val="accent1">
+              <a:shade val="50000"/>
+            </a:schemeClr>
+          </a:lnRef>
+          <a:fillRef idx="1">
+            <a:schemeClr val="accent1"/>
+          </a:fillRef>
+          <a:effectRef idx="0">
+            <a:schemeClr val="accent1"/>
+          </a:effectRef>
+          <a:fontRef idx="minor">
+            <a:schemeClr val="lt1"/>
+          </a:fontRef>
+        </p:style>
+        <p:txBody>
+          <a:bodyPr rtlCol="0" anchor="ctr"/>
+          <a:lstStyle/>
+          <a:p>
+            <a:pPr algn="ctr"/>
+            <a:endParaRPr lang="en-US"/>
+          </a:p>
+        </p:txBody>
+      </p:sp>
+      <p:sp>
+        <p:nvSpPr>
+          <p:cNvPr id="4" name="Textfeld 3">
+            <a:extLst>
+              <a:ext uri="{FF2B5EF4-FFF2-40B4-BE49-F238E27FC236}">
+                <a16:creationId xmlns:a16="http://schemas.microsoft.com/office/drawing/2014/main" id="{2E108825-AC23-4A2A-BBA3-94A253E62C8A}"/>
+              </a:ext>
+            </a:extLst>
+          </p:cNvPr>
+          <p:cNvSpPr txBox="1"/>
+          <p:nvPr/>
+        </p:nvSpPr>
+        <p:spPr>
+          <a:xfrm>
+            <a:off x="6274217" y="1096072"/>
+            <a:ext cx="4153814" cy="400110"/>
+          </a:xfrm>
+          <a:prstGeom prst="rect">
+            <a:avLst/>
+          </a:prstGeom>
+          <a:noFill/>
+        </p:spPr>
+        <p:txBody>
+          <a:bodyPr wrap="square" rtlCol="0">
+            <a:spAutoFit/>
+          </a:bodyPr>
+          <a:lstStyle/>
+          <a:p>
+            <a:r>
+              <a:rPr lang="en-US" sz="2000" b="1" dirty="0"/>
+              <a:t>Confusion Matrix for tuned LightGBM</a:t>
+            </a:r>
+          </a:p>
+        </p:txBody>
+      </p:sp>
     </p:spTree>
     <p:extLst>
       <p:ext uri="{BB962C8B-B14F-4D97-AF65-F5344CB8AC3E}">
@@ -11274,12 +11526,70 @@
           <a:chExt cx="0" cy="0"/>
         </a:xfrm>
       </p:grpSpPr>
+      <p:sp>
+        <p:nvSpPr>
+          <p:cNvPr id="2" name="Titel 1">
+            <a:extLst>
+              <a:ext uri="{FF2B5EF4-FFF2-40B4-BE49-F238E27FC236}">
+                <a16:creationId xmlns:a16="http://schemas.microsoft.com/office/drawing/2014/main" id="{82B9FC66-7716-AB35-789F-4708D1BEEA29}"/>
+              </a:ext>
+            </a:extLst>
+          </p:cNvPr>
+          <p:cNvSpPr>
+            <a:spLocks noGrp="1"/>
+          </p:cNvSpPr>
+          <p:nvPr>
+            <p:ph type="title"/>
+          </p:nvPr>
+        </p:nvSpPr>
+        <p:spPr/>
+        <p:txBody>
+          <a:bodyPr/>
+          <a:lstStyle/>
+          <a:p>
+            <a:r>
+              <a:rPr lang="de-DE" dirty="0"/>
+              <a:t>RQ3: Global Feature </a:t>
+            </a:r>
+            <a:r>
+              <a:rPr lang="de-DE" dirty="0" err="1"/>
+              <a:t>Importances</a:t>
+            </a:r>
+            <a:endParaRPr lang="de-DE" dirty="0"/>
+          </a:p>
+        </p:txBody>
+      </p:sp>
+      <p:sp>
+        <p:nvSpPr>
+          <p:cNvPr id="50" name="Fußzeilenplatzhalter 49">
+            <a:extLst>
+              <a:ext uri="{FF2B5EF4-FFF2-40B4-BE49-F238E27FC236}">
+                <a16:creationId xmlns:a16="http://schemas.microsoft.com/office/drawing/2014/main" id="{7CD51831-BA02-4446-AE31-9DDAB186668A}"/>
+              </a:ext>
+            </a:extLst>
+          </p:cNvPr>
+          <p:cNvSpPr>
+            <a:spLocks noGrp="1"/>
+          </p:cNvSpPr>
+          <p:nvPr>
+            <p:ph type="ftr" sz="quarter" idx="11"/>
+          </p:nvPr>
+        </p:nvSpPr>
+        <p:spPr/>
+        <p:txBody>
+          <a:bodyPr/>
+          <a:lstStyle/>
+          <a:p>
+            <a:endParaRPr lang="de-DE"/>
+          </a:p>
+        </p:txBody>
+      </p:sp>
       <p:pic>
         <p:nvPicPr>
-          <p:cNvPr id="5" name="Grafik 4">
+          <p:cNvPr id="8" name="Grafik 7">
             <a:extLst>
               <a:ext uri="{FF2B5EF4-FFF2-40B4-BE49-F238E27FC236}">
-                <a16:creationId xmlns:a16="http://schemas.microsoft.com/office/drawing/2014/main" id="{DD7D7A48-5746-5469-127A-483AB02E3A1C}"/>
+                <a16:creationId xmlns:a16="http://schemas.microsoft.com/office/drawing/2014/main" id="{EB782565-E78E-91CA-3083-4C2ABC888990}"/>
               </a:ext>
             </a:extLst>
           </p:cNvPr>
@@ -11289,123 +11599,21 @@
           <p:nvPr/>
         </p:nvPicPr>
         <p:blipFill>
-          <a:blip r:embed="rId3" cstate="print">
-            <a:extLst>
-              <a:ext uri="{28A0092B-C50C-407E-A947-70E740481C1C}">
-                <a14:useLocalDpi xmlns:a14="http://schemas.microsoft.com/office/drawing/2010/main" val="0"/>
+          <a:blip>
+            <a:extLst>
+              <a:ext uri="{96DAC541-7B7A-43D3-8B79-37D633B846F1}">
+                <asvg:svgBlip xmlns:asvg="http://schemas.microsoft.com/office/drawing/2016/SVG/main" r:embed="rId3"/>
               </a:ext>
             </a:extLst>
           </a:blip>
-          <a:srcRect r="3191"/>
           <a:stretch>
             <a:fillRect/>
           </a:stretch>
         </p:blipFill>
         <p:spPr>
           <a:xfrm>
-            <a:off x="163800" y="2382930"/>
-            <a:ext cx="6552727" cy="2820314"/>
-          </a:xfrm>
-          <a:prstGeom prst="rect">
-            <a:avLst/>
-          </a:prstGeom>
-        </p:spPr>
-      </p:pic>
-      <p:sp>
-        <p:nvSpPr>
-          <p:cNvPr id="2" name="Titel 1">
-            <a:extLst>
-              <a:ext uri="{FF2B5EF4-FFF2-40B4-BE49-F238E27FC236}">
-                <a16:creationId xmlns:a16="http://schemas.microsoft.com/office/drawing/2014/main" id="{82B9FC66-7716-AB35-789F-4708D1BEEA29}"/>
-              </a:ext>
-            </a:extLst>
-          </p:cNvPr>
-          <p:cNvSpPr>
-            <a:spLocks noGrp="1"/>
-          </p:cNvSpPr>
-          <p:nvPr>
-            <p:ph type="title"/>
-          </p:nvPr>
-        </p:nvSpPr>
-        <p:spPr/>
-        <p:txBody>
-          <a:bodyPr/>
-          <a:lstStyle/>
-          <a:p>
-            <a:r>
-              <a:rPr lang="de-DE" dirty="0"/>
-              <a:t>RQ3: Global and </a:t>
-            </a:r>
-            <a:r>
-              <a:rPr lang="de-DE" dirty="0" err="1"/>
-              <a:t>Local</a:t>
-            </a:r>
-            <a:r>
-              <a:rPr lang="de-DE" dirty="0"/>
-              <a:t> Feature </a:t>
-            </a:r>
-            <a:r>
-              <a:rPr lang="de-DE" dirty="0" err="1"/>
-              <a:t>Importances</a:t>
-            </a:r>
-            <a:endParaRPr lang="de-DE" dirty="0"/>
-          </a:p>
-        </p:txBody>
-      </p:sp>
-      <p:sp>
-        <p:nvSpPr>
-          <p:cNvPr id="50" name="Fußzeilenplatzhalter 49">
-            <a:extLst>
-              <a:ext uri="{FF2B5EF4-FFF2-40B4-BE49-F238E27FC236}">
-                <a16:creationId xmlns:a16="http://schemas.microsoft.com/office/drawing/2014/main" id="{7CD51831-BA02-4446-AE31-9DDAB186668A}"/>
-              </a:ext>
-            </a:extLst>
-          </p:cNvPr>
-          <p:cNvSpPr>
-            <a:spLocks noGrp="1"/>
-          </p:cNvSpPr>
-          <p:nvPr>
-            <p:ph type="ftr" sz="quarter" idx="11"/>
-          </p:nvPr>
-        </p:nvSpPr>
-        <p:spPr/>
-        <p:txBody>
-          <a:bodyPr/>
-          <a:lstStyle/>
-          <a:p>
-            <a:endParaRPr lang="de-DE"/>
-          </a:p>
-        </p:txBody>
-      </p:sp>
-      <p:pic>
-        <p:nvPicPr>
-          <p:cNvPr id="7" name="Grafik 6">
-            <a:extLst>
-              <a:ext uri="{FF2B5EF4-FFF2-40B4-BE49-F238E27FC236}">
-                <a16:creationId xmlns:a16="http://schemas.microsoft.com/office/drawing/2014/main" id="{40766A6E-E996-DB07-2ED8-6EA37235BECC}"/>
-              </a:ext>
-            </a:extLst>
-          </p:cNvPr>
-          <p:cNvPicPr>
-            <a:picLocks noChangeAspect="1"/>
-          </p:cNvPicPr>
-          <p:nvPr/>
-        </p:nvPicPr>
-        <p:blipFill>
-          <a:blip r:embed="rId4" cstate="print">
-            <a:extLst>
-              <a:ext uri="{28A0092B-C50C-407E-A947-70E740481C1C}">
-                <a14:useLocalDpi xmlns:a14="http://schemas.microsoft.com/office/drawing/2010/main" val="0"/>
-              </a:ext>
-            </a:extLst>
-          </a:blip>
-          <a:srcRect/>
-          <a:stretch/>
-        </p:blipFill>
-        <p:spPr>
-          <a:xfrm>
-            <a:off x="6887818" y="1484784"/>
-            <a:ext cx="5140382" cy="4616606"/>
+            <a:off x="1991544" y="1412776"/>
+            <a:ext cx="7879580" cy="4882356"/>
           </a:xfrm>
           <a:prstGeom prst="rect">
             <a:avLst/>
@@ -12798,7 +13006,7 @@
             </a:r>
             <a:r>
               <a:rPr lang="de-DE" sz="2000" dirty="0"/>
-              <a:t> 83,3% </a:t>
+              <a:t> 83,2% </a:t>
             </a:r>
             <a:r>
               <a:rPr lang="de-DE" sz="2000" dirty="0" err="1"/>
@@ -12831,7 +13039,7 @@
         <p:spPr>
           <a:xfrm>
             <a:off x="8160229" y="2996951"/>
-            <a:ext cx="3600400" cy="2908489"/>
+            <a:ext cx="3600400" cy="3524042"/>
           </a:xfrm>
           <a:prstGeom prst="rect">
             <a:avLst/>
@@ -13004,6 +13212,72 @@
                 <a:cs typeface="Calibri Light" panose="020F0302020204030204" pitchFamily="34" charset="0"/>
               </a:rPr>
               <a:t>sentiment</a:t>
+            </a:r>
+            <a:r>
+              <a:rPr lang="de-DE" sz="2000" dirty="0">
+                <a:latin typeface="+mj-lt"/>
+                <a:ea typeface="Calibri Light" panose="020F0302020204030204" pitchFamily="34" charset="0"/>
+                <a:cs typeface="Calibri Light" panose="020F0302020204030204" pitchFamily="34" charset="0"/>
+              </a:rPr>
+              <a:t>; </a:t>
+            </a:r>
+          </a:p>
+          <a:p>
+            <a:r>
+              <a:rPr lang="de-DE" sz="2000" dirty="0" err="1">
+                <a:latin typeface="+mj-lt"/>
+                <a:ea typeface="Calibri Light" panose="020F0302020204030204" pitchFamily="34" charset="0"/>
+                <a:cs typeface="Calibri Light" panose="020F0302020204030204" pitchFamily="34" charset="0"/>
+              </a:rPr>
+              <a:t>Some</a:t>
+            </a:r>
+            <a:r>
+              <a:rPr lang="de-DE" sz="2000" dirty="0">
+                <a:latin typeface="+mj-lt"/>
+                <a:ea typeface="Calibri Light" panose="020F0302020204030204" pitchFamily="34" charset="0"/>
+                <a:cs typeface="Calibri Light" panose="020F0302020204030204" pitchFamily="34" charset="0"/>
+              </a:rPr>
+              <a:t> </a:t>
+            </a:r>
+            <a:r>
+              <a:rPr lang="de-DE" sz="2000" dirty="0" err="1">
+                <a:latin typeface="+mj-lt"/>
+                <a:ea typeface="Calibri Light" panose="020F0302020204030204" pitchFamily="34" charset="0"/>
+                <a:cs typeface="Calibri Light" panose="020F0302020204030204" pitchFamily="34" charset="0"/>
+              </a:rPr>
+              <a:t>expression</a:t>
+            </a:r>
+            <a:r>
+              <a:rPr lang="de-DE" sz="2000" dirty="0">
+                <a:latin typeface="+mj-lt"/>
+                <a:ea typeface="Calibri Light" panose="020F0302020204030204" pitchFamily="34" charset="0"/>
+                <a:cs typeface="Calibri Light" panose="020F0302020204030204" pitchFamily="34" charset="0"/>
+              </a:rPr>
+              <a:t> </a:t>
+            </a:r>
+            <a:r>
+              <a:rPr lang="de-DE" sz="2000" dirty="0" err="1">
+                <a:latin typeface="+mj-lt"/>
+                <a:ea typeface="Calibri Light" panose="020F0302020204030204" pitchFamily="34" charset="0"/>
+                <a:cs typeface="Calibri Light" panose="020F0302020204030204" pitchFamily="34" charset="0"/>
+              </a:rPr>
+              <a:t>types</a:t>
+            </a:r>
+            <a:r>
+              <a:rPr lang="de-DE" sz="2000" dirty="0">
+                <a:latin typeface="+mj-lt"/>
+                <a:ea typeface="Calibri Light" panose="020F0302020204030204" pitchFamily="34" charset="0"/>
+                <a:cs typeface="Calibri Light" panose="020F0302020204030204" pitchFamily="34" charset="0"/>
+              </a:rPr>
+              <a:t> to not </a:t>
+            </a:r>
+            <a:r>
+              <a:rPr lang="de-DE" sz="2000" dirty="0" err="1">
+                <a:latin typeface="+mj-lt"/>
+                <a:ea typeface="Calibri Light" panose="020F0302020204030204" pitchFamily="34" charset="0"/>
+                <a:cs typeface="Calibri Light" panose="020F0302020204030204" pitchFamily="34" charset="0"/>
+              </a:rPr>
+              <a:t>generalize</a:t>
             </a:r>
             <a:endParaRPr lang="de-DE" sz="2000" dirty="0">
               <a:latin typeface="+mj-lt"/>
@@ -13461,7 +13735,7 @@
                 <a:ea typeface="Calibri Light" panose="020F0302020204030204" pitchFamily="34" charset="0"/>
                 <a:cs typeface="Calibri Light" panose="020F0302020204030204" pitchFamily="34" charset="0"/>
               </a:rPr>
-              <a:t>2,3</a:t>
+              <a:t>1,2</a:t>
             </a:r>
             <a:r>
               <a:rPr lang="en-US" sz="2000" b="0" dirty="0">
@@ -13501,7 +13775,15 @@
             </a:r>
             <a:r>
               <a:rPr lang="de-DE" dirty="0"/>
-              <a:t>Frith (1986)   </a:t>
+              <a:t>Napier &amp; </a:t>
+            </a:r>
+            <a:r>
+              <a:rPr lang="de-DE" dirty="0" err="1"/>
+              <a:t>Shamir</a:t>
+            </a:r>
+            <a:r>
+              <a:rPr lang="de-DE" dirty="0"/>
+              <a:t> (2018)  </a:t>
             </a:r>
             <a:r>
               <a:rPr lang="de-DE" baseline="30000" dirty="0"/>
@@ -13509,15 +13791,7 @@
             </a:r>
             <a:r>
               <a:rPr lang="de-DE" dirty="0"/>
-              <a:t>Napier &amp; </a:t>
-            </a:r>
-            <a:r>
-              <a:rPr lang="de-DE" dirty="0" err="1"/>
-              <a:t>Shamir</a:t>
-            </a:r>
-            <a:r>
-              <a:rPr lang="de-DE" dirty="0"/>
-              <a:t> (2018)  </a:t>
+              <a:t>Brandl et al. (2019)   </a:t>
             </a:r>
             <a:r>
               <a:rPr lang="de-DE" baseline="30000" dirty="0"/>
@@ -13525,7 +13799,7 @@
             </a:r>
             <a:r>
               <a:rPr lang="de-DE" dirty="0"/>
-              <a:t>Brandl et al. (2019)   </a:t>
+              <a:t>Fell &amp; Sporleder (2014)   </a:t>
             </a:r>
             <a:r>
               <a:rPr lang="de-DE" baseline="30000" dirty="0"/>
@@ -13533,19 +13807,11 @@
             </a:r>
             <a:r>
               <a:rPr lang="de-DE" dirty="0"/>
-              <a:t>Fell &amp; Sporleder (2014)   </a:t>
+              <a:t>Rudin (2019)   </a:t>
             </a:r>
             <a:r>
               <a:rPr lang="de-DE" baseline="30000" dirty="0"/>
               <a:t>5 </a:t>
-            </a:r>
-            <a:r>
-              <a:rPr lang="de-DE" dirty="0"/>
-              <a:t>Rudin (2019)   </a:t>
-            </a:r>
-            <a:r>
-              <a:rPr lang="de-DE" baseline="30000" dirty="0"/>
-              <a:t>6 </a:t>
             </a:r>
             <a:r>
               <a:rPr lang="de-DE" dirty="0" err="1"/>
@@ -13796,7 +14062,7 @@
         </p:spPr>
         <p:txBody>
           <a:bodyPr vert="horz" lIns="91440" tIns="45720" rIns="91440" bIns="45720" rtlCol="0">
-            <a:normAutofit/>
+            <a:normAutofit lnSpcReduction="10000"/>
           </a:bodyPr>
           <a:lstStyle>
             <a:lvl1pPr marL="342900" indent="-342900" algn="l" defTabSz="914400" rtl="0" eaLnBrk="1" latinLnBrk="0" hangingPunct="1">
@@ -13940,6 +14206,14 @@
               <a:buNone/>
             </a:pPr>
             <a:r>
+              <a:rPr lang="en-US" sz="2000" b="0" dirty="0">
+                <a:latin typeface="Calibri Light" panose="020F0302020204030204" pitchFamily="34" charset="0"/>
+                <a:ea typeface="Calibri Light" panose="020F0302020204030204" pitchFamily="34" charset="0"/>
+                <a:cs typeface="Calibri Light" panose="020F0302020204030204" pitchFamily="34" charset="0"/>
+              </a:rPr>
+              <a:t>Show that </a:t>
+            </a:r>
+            <a:r>
               <a:rPr lang="en-US" sz="2000" dirty="0">
                 <a:latin typeface="+mj-lt"/>
                 <a:ea typeface="Calibri Light" panose="020F0302020204030204" pitchFamily="34" charset="0"/>
@@ -13961,23 +14235,7 @@
                 <a:ea typeface="Calibri Light" panose="020F0302020204030204" pitchFamily="34" charset="0"/>
                 <a:cs typeface="Calibri Light" panose="020F0302020204030204" pitchFamily="34" charset="0"/>
               </a:rPr>
-              <a:t>phrasing important for stylistic discrimination</a:t>
-            </a:r>
-            <a:r>
-              <a:rPr lang="en-US" sz="2000" b="0" baseline="30000" dirty="0">
-                <a:latin typeface="Calibri Light" panose="020F0302020204030204" pitchFamily="34" charset="0"/>
-                <a:ea typeface="Calibri Light" panose="020F0302020204030204" pitchFamily="34" charset="0"/>
-                <a:cs typeface="Calibri Light" panose="020F0302020204030204" pitchFamily="34" charset="0"/>
-              </a:rPr>
-              <a:t>1</a:t>
-            </a:r>
-            <a:r>
-              <a:rPr lang="en-US" sz="2000" b="0" dirty="0">
-                <a:latin typeface="Calibri Light" panose="020F0302020204030204" pitchFamily="34" charset="0"/>
-                <a:ea typeface="Calibri Light" panose="020F0302020204030204" pitchFamily="34" charset="0"/>
-                <a:cs typeface="Calibri Light" panose="020F0302020204030204" pitchFamily="34" charset="0"/>
-              </a:rPr>
-              <a:t> (RQ1)</a:t>
+              <a:t>phrasing more important for stylistic discrimination than topics and sentiments (RQ1+3)</a:t>
             </a:r>
             <a:endParaRPr lang="en-US" sz="2000" b="0" baseline="30000" dirty="0">
               <a:latin typeface="Calibri Light" panose="020F0302020204030204" pitchFamily="34" charset="0"/>
@@ -14221,7 +14479,7 @@
                 <a:ea typeface="Calibri Light" panose="020F0302020204030204" pitchFamily="34" charset="0"/>
                 <a:cs typeface="Calibri Light" panose="020F0302020204030204" pitchFamily="34" charset="0"/>
               </a:rPr>
-              <a:t>4</a:t>
+              <a:t>3</a:t>
             </a:r>
             <a:r>
               <a:rPr lang="en-US" sz="2000" b="0" dirty="0">
@@ -14555,7 +14813,7 @@
                 <a:ea typeface="Calibri Light" panose="020F0302020204030204" pitchFamily="34" charset="0"/>
                 <a:cs typeface="Calibri Light" panose="020F0302020204030204" pitchFamily="34" charset="0"/>
               </a:rPr>
-              <a:t>5,6</a:t>
+              <a:t>4,5</a:t>
             </a:r>
           </a:p>
         </p:txBody>
@@ -15164,10 +15422,10 @@
       </p:sp>
       <p:pic>
         <p:nvPicPr>
-          <p:cNvPr id="8" name="Grafik 7" descr="Würfel Silhouette">
+          <p:cNvPr id="12" name="Grafik 11" descr="Erdkugel: Amerika mit einfarbiger Füllung">
             <a:extLst>
               <a:ext uri="{FF2B5EF4-FFF2-40B4-BE49-F238E27FC236}">
-                <a16:creationId xmlns:a16="http://schemas.microsoft.com/office/drawing/2014/main" id="{0E386F13-8A02-7802-9BBD-8EBAB8FB7B4F}"/>
+                <a16:creationId xmlns:a16="http://schemas.microsoft.com/office/drawing/2014/main" id="{69638E55-A394-15C0-1D12-3579433D3665}"/>
               </a:ext>
             </a:extLst>
           </p:cNvPr>
@@ -15181,42 +15439,6 @@
             <a:extLst>
               <a:ext uri="{96DAC541-7B7A-43D3-8B79-37D633B846F1}">
                 <asvg:svgBlip xmlns:asvg="http://schemas.microsoft.com/office/drawing/2016/SVG/main" r:embed="rId2"/>
-              </a:ext>
-            </a:extLst>
-          </a:blip>
-          <a:stretch>
-            <a:fillRect/>
-          </a:stretch>
-        </p:blipFill>
-        <p:spPr>
-          <a:xfrm>
-            <a:off x="7908301" y="754674"/>
-            <a:ext cx="914400" cy="914400"/>
-          </a:xfrm>
-          <a:prstGeom prst="rect">
-            <a:avLst/>
-          </a:prstGeom>
-        </p:spPr>
-      </p:pic>
-      <p:pic>
-        <p:nvPicPr>
-          <p:cNvPr id="12" name="Grafik 11" descr="Erdkugel: Amerika mit einfarbiger Füllung">
-            <a:extLst>
-              <a:ext uri="{FF2B5EF4-FFF2-40B4-BE49-F238E27FC236}">
-                <a16:creationId xmlns:a16="http://schemas.microsoft.com/office/drawing/2014/main" id="{69638E55-A394-15C0-1D12-3579433D3665}"/>
-              </a:ext>
-            </a:extLst>
-          </p:cNvPr>
-          <p:cNvPicPr>
-            <a:picLocks noChangeAspect="1"/>
-          </p:cNvPicPr>
-          <p:nvPr/>
-        </p:nvPicPr>
-        <p:blipFill>
-          <a:blip>
-            <a:extLst>
-              <a:ext uri="{96DAC541-7B7A-43D3-8B79-37D633B846F1}">
-                <asvg:svgBlip xmlns:asvg="http://schemas.microsoft.com/office/drawing/2016/SVG/main" r:embed="rId3"/>
               </a:ext>
             </a:extLst>
           </a:blip>
@@ -15249,7 +15471,7 @@
         <p:spPr>
           <a:xfrm>
             <a:off x="706348" y="1829280"/>
-            <a:ext cx="5616624" cy="1631216"/>
+            <a:ext cx="5616624" cy="1836400"/>
           </a:xfrm>
           <a:prstGeom prst="rect">
             <a:avLst/>
@@ -15302,19 +15524,83 @@
               </a:rPr>
               <a:t>1 </a:t>
             </a:r>
+          </a:p>
+          <a:p>
+            <a:endParaRPr lang="en-US" sz="2000" baseline="30000" dirty="0">
+              <a:latin typeface="Calibri Light" panose="020F0302020204030204" pitchFamily="34" charset="0"/>
+              <a:ea typeface="Calibri Light" panose="020F0302020204030204" pitchFamily="34" charset="0"/>
+              <a:cs typeface="Calibri Light" panose="020F0302020204030204" pitchFamily="34" charset="0"/>
+            </a:endParaRPr>
+          </a:p>
+          <a:p>
+            <a:r>
+              <a:rPr lang="en-US" sz="2000" dirty="0">
+                <a:latin typeface="Calibri Light" panose="020F0302020204030204" pitchFamily="34" charset="0"/>
+                <a:ea typeface="Calibri Light" panose="020F0302020204030204" pitchFamily="34" charset="0"/>
+                <a:cs typeface="Calibri Light" panose="020F0302020204030204" pitchFamily="34" charset="0"/>
+              </a:rPr>
+              <a:t>Multilabel reduced to </a:t>
+            </a:r>
+            <a:r>
+              <a:rPr lang="en-US" sz="2000" b="1" dirty="0">
+                <a:latin typeface="Calibri "/>
+                <a:ea typeface="Calibri Light" panose="020F0302020204030204" pitchFamily="34" charset="0"/>
+                <a:cs typeface="Calibri Light" panose="020F0302020204030204" pitchFamily="34" charset="0"/>
+              </a:rPr>
+              <a:t>single label assignments </a:t>
+            </a:r>
+            <a:br>
+              <a:rPr lang="en-US" sz="2000" b="1" dirty="0">
+                <a:latin typeface="Calibri "/>
+                <a:ea typeface="Calibri Light" panose="020F0302020204030204" pitchFamily="34" charset="0"/>
+                <a:cs typeface="Calibri Light" panose="020F0302020204030204" pitchFamily="34" charset="0"/>
+              </a:rPr>
+            </a:br>
+            <a:r>
+              <a:rPr lang="en-US" sz="2000" dirty="0">
+                <a:latin typeface="Calibri Light" panose="020F0302020204030204" pitchFamily="34" charset="0"/>
+                <a:ea typeface="Calibri Light" panose="020F0302020204030204" pitchFamily="34" charset="0"/>
+                <a:cs typeface="Calibri Light" panose="020F0302020204030204" pitchFamily="34" charset="0"/>
+              </a:rPr>
+              <a:t>for interpretability</a:t>
+            </a:r>
+          </a:p>
+          <a:p>
             <a:endParaRPr lang="en-US" sz="2000" dirty="0">
               <a:latin typeface="Calibri Light" panose="020F0302020204030204" pitchFamily="34" charset="0"/>
               <a:ea typeface="Calibri Light" panose="020F0302020204030204" pitchFamily="34" charset="0"/>
               <a:cs typeface="Calibri Light" panose="020F0302020204030204" pitchFamily="34" charset="0"/>
             </a:endParaRPr>
           </a:p>
-          <a:p>
-            <a:endParaRPr lang="en-US" sz="2000" dirty="0">
-              <a:latin typeface="Calibri Light" panose="020F0302020204030204" pitchFamily="34" charset="0"/>
-              <a:ea typeface="Calibri Light" panose="020F0302020204030204" pitchFamily="34" charset="0"/>
-              <a:cs typeface="Calibri Light" panose="020F0302020204030204" pitchFamily="34" charset="0"/>
-            </a:endParaRPr>
-          </a:p>
+        </p:txBody>
+      </p:sp>
+      <p:sp>
+        <p:nvSpPr>
+          <p:cNvPr id="15" name="Textfeld 14">
+            <a:extLst>
+              <a:ext uri="{FF2B5EF4-FFF2-40B4-BE49-F238E27FC236}">
+                <a16:creationId xmlns:a16="http://schemas.microsoft.com/office/drawing/2014/main" id="{3F851575-E770-80BF-FFD5-32FDC5B4EF57}"/>
+              </a:ext>
+            </a:extLst>
+          </p:cNvPr>
+          <p:cNvSpPr txBox="1"/>
+          <p:nvPr/>
+        </p:nvSpPr>
+        <p:spPr>
+          <a:xfrm>
+            <a:off x="6096000" y="1823885"/>
+            <a:ext cx="5716897" cy="707886"/>
+          </a:xfrm>
+          <a:prstGeom prst="rect">
+            <a:avLst/>
+          </a:prstGeom>
+          <a:noFill/>
+        </p:spPr>
+        <p:txBody>
+          <a:bodyPr wrap="square" rtlCol="0">
+            <a:spAutoFit/>
+          </a:bodyPr>
+          <a:lstStyle/>
           <a:p>
             <a:r>
               <a:rPr lang="en-US" sz="2000" dirty="0">
@@ -15350,114 +15636,11 @@
             </a:r>
             <a:r>
               <a:rPr lang="en-US" sz="2000" b="1" dirty="0">
-                <a:latin typeface="+mj-lt"/>
                 <a:ea typeface="Calibri Light" panose="020F0302020204030204" pitchFamily="34" charset="0"/>
                 <a:cs typeface="Calibri Light" panose="020F0302020204030204" pitchFamily="34" charset="0"/>
               </a:rPr>
               <a:t>single label categories</a:t>
             </a:r>
-          </a:p>
-        </p:txBody>
-      </p:sp>
-      <p:sp>
-        <p:nvSpPr>
-          <p:cNvPr id="15" name="Textfeld 14">
-            <a:extLst>
-              <a:ext uri="{FF2B5EF4-FFF2-40B4-BE49-F238E27FC236}">
-                <a16:creationId xmlns:a16="http://schemas.microsoft.com/office/drawing/2014/main" id="{3F851575-E770-80BF-FFD5-32FDC5B4EF57}"/>
-              </a:ext>
-            </a:extLst>
-          </p:cNvPr>
-          <p:cNvSpPr txBox="1"/>
-          <p:nvPr/>
-        </p:nvSpPr>
-        <p:spPr>
-          <a:xfrm>
-            <a:off x="6096000" y="1823885"/>
-            <a:ext cx="5716897" cy="1631216"/>
-          </a:xfrm>
-          <a:prstGeom prst="rect">
-            <a:avLst/>
-          </a:prstGeom>
-          <a:noFill/>
-        </p:spPr>
-        <p:txBody>
-          <a:bodyPr wrap="square" rtlCol="0">
-            <a:spAutoFit/>
-          </a:bodyPr>
-          <a:lstStyle/>
-          <a:p>
-            <a:r>
-              <a:rPr lang="en-US" sz="2000" b="1" dirty="0"/>
-              <a:t>feature collinearity </a:t>
-            </a:r>
-            <a:r>
-              <a:rPr lang="en-US" sz="2000" dirty="0">
-                <a:latin typeface="Calibri Light" panose="020F0302020204030204" pitchFamily="34" charset="0"/>
-                <a:ea typeface="Calibri Light" panose="020F0302020204030204" pitchFamily="34" charset="0"/>
-                <a:cs typeface="Calibri Light" panose="020F0302020204030204" pitchFamily="34" charset="0"/>
-              </a:rPr>
-              <a:t>might shuffle </a:t>
-            </a:r>
-            <a:br>
-              <a:rPr lang="en-US" sz="2000" dirty="0">
-                <a:latin typeface="Calibri Light" panose="020F0302020204030204" pitchFamily="34" charset="0"/>
-                <a:ea typeface="Calibri Light" panose="020F0302020204030204" pitchFamily="34" charset="0"/>
-                <a:cs typeface="Calibri Light" panose="020F0302020204030204" pitchFamily="34" charset="0"/>
-              </a:rPr>
-            </a:br>
-            <a:r>
-              <a:rPr lang="en-US" sz="2000" dirty="0">
-                <a:latin typeface="Calibri Light" panose="020F0302020204030204" pitchFamily="34" charset="0"/>
-                <a:ea typeface="Calibri Light" panose="020F0302020204030204" pitchFamily="34" charset="0"/>
-                <a:cs typeface="Calibri Light" panose="020F0302020204030204" pitchFamily="34" charset="0"/>
-              </a:rPr>
-              <a:t>variable importance</a:t>
-            </a:r>
-          </a:p>
-          <a:p>
-            <a:endParaRPr lang="en-US" sz="2000" dirty="0">
-              <a:latin typeface="Calibri Light" panose="020F0302020204030204" pitchFamily="34" charset="0"/>
-              <a:ea typeface="Calibri Light" panose="020F0302020204030204" pitchFamily="34" charset="0"/>
-              <a:cs typeface="Calibri Light" panose="020F0302020204030204" pitchFamily="34" charset="0"/>
-            </a:endParaRPr>
-          </a:p>
-          <a:p>
-            <a:r>
-              <a:rPr lang="en-US" sz="2000" dirty="0">
-                <a:latin typeface="Calibri Light" panose="020F0302020204030204" pitchFamily="34" charset="0"/>
-                <a:ea typeface="Calibri Light" panose="020F0302020204030204" pitchFamily="34" charset="0"/>
-                <a:cs typeface="Calibri Light" panose="020F0302020204030204" pitchFamily="34" charset="0"/>
-              </a:rPr>
-              <a:t>Generalizability </a:t>
-            </a:r>
-            <a:r>
-              <a:rPr lang="en-US" sz="2000" b="1" dirty="0">
-                <a:latin typeface="Calibri Textkörper"/>
-                <a:ea typeface="Calibri Light" panose="020F0302020204030204" pitchFamily="34" charset="0"/>
-                <a:cs typeface="Calibri Light" panose="020F0302020204030204" pitchFamily="34" charset="0"/>
-              </a:rPr>
-              <a:t>beyond Anglophone music </a:t>
-            </a:r>
-            <a:r>
-              <a:rPr lang="en-US" sz="2000" dirty="0">
-                <a:latin typeface="Calibri Light" panose="020F0302020204030204" pitchFamily="34" charset="0"/>
-                <a:ea typeface="Calibri Light" panose="020F0302020204030204" pitchFamily="34" charset="0"/>
-                <a:cs typeface="Calibri Light" panose="020F0302020204030204" pitchFamily="34" charset="0"/>
-              </a:rPr>
-              <a:t>listened to in </a:t>
-            </a:r>
-            <a:r>
-              <a:rPr lang="en-US" sz="2000" b="1" dirty="0">
-                <a:latin typeface="Calibri Textkörper"/>
-                <a:ea typeface="Calibri Light" panose="020F0302020204030204" pitchFamily="34" charset="0"/>
-                <a:cs typeface="Calibri Light" panose="020F0302020204030204" pitchFamily="34" charset="0"/>
-              </a:rPr>
-              <a:t>Germany</a:t>
-            </a:r>
-            <a:endParaRPr lang="en-US" sz="2000" b="1" dirty="0">
-              <a:latin typeface="Calibri Textkörper"/>
-            </a:endParaRPr>
           </a:p>
         </p:txBody>
       </p:sp>
@@ -15503,6 +15686,22 @@
             </a:r>
             <a:r>
               <a:rPr lang="en-US" sz="2000" b="1" dirty="0">
+                <a:latin typeface="Calibri "/>
+                <a:ea typeface="Calibri Light" panose="020F0302020204030204" pitchFamily="34" charset="0"/>
+                <a:cs typeface="Calibri Light" panose="020F0302020204030204" pitchFamily="34" charset="0"/>
+              </a:rPr>
+              <a:t>other corpora</a:t>
+            </a:r>
+            <a:r>
+              <a:rPr lang="en-US" sz="2000" dirty="0">
+                <a:latin typeface="Calibri Light" panose="020F0302020204030204" pitchFamily="34" charset="0"/>
+                <a:ea typeface="Calibri Light" panose="020F0302020204030204" pitchFamily="34" charset="0"/>
+                <a:cs typeface="Calibri Light" panose="020F0302020204030204" pitchFamily="34" charset="0"/>
+              </a:rPr>
+              <a:t>, </a:t>
+            </a:r>
+            <a:r>
+              <a:rPr lang="en-US" sz="2000" b="1" dirty="0">
                 <a:latin typeface="+mj-lt"/>
                 <a:ea typeface="Calibri Light" panose="020F0302020204030204" pitchFamily="34" charset="0"/>
                 <a:cs typeface="Calibri Light" panose="020F0302020204030204" pitchFamily="34" charset="0"/>
@@ -15724,12 +15923,81 @@
           </a:p>
         </p:txBody>
       </p:sp>
+      <p:sp>
+        <p:nvSpPr>
+          <p:cNvPr id="3" name="Fußzeilenplatzhalter 2">
+            <a:extLst>
+              <a:ext uri="{FF2B5EF4-FFF2-40B4-BE49-F238E27FC236}">
+                <a16:creationId xmlns:a16="http://schemas.microsoft.com/office/drawing/2014/main" id="{76194510-C1D1-C540-FE2E-A3CD8BDDDA1E}"/>
+              </a:ext>
+            </a:extLst>
+          </p:cNvPr>
+          <p:cNvSpPr>
+            <a:spLocks noGrp="1"/>
+          </p:cNvSpPr>
+          <p:nvPr>
+            <p:ph type="ftr" sz="quarter" idx="11"/>
+          </p:nvPr>
+        </p:nvSpPr>
+        <p:spPr>
+          <a:xfrm>
+            <a:off x="468429" y="6356351"/>
+            <a:ext cx="11292199" cy="365125"/>
+          </a:xfrm>
+        </p:spPr>
+        <p:txBody>
+          <a:bodyPr/>
+          <a:lstStyle/>
+          <a:p>
+            <a:r>
+              <a:rPr lang="de-DE" baseline="30000" dirty="0"/>
+              <a:t>1 </a:t>
+            </a:r>
+            <a:r>
+              <a:rPr lang="de-DE" dirty="0"/>
+              <a:t>van </a:t>
+            </a:r>
+            <a:r>
+              <a:rPr lang="de-DE" dirty="0" err="1"/>
+              <a:t>Venrooj</a:t>
+            </a:r>
+            <a:r>
+              <a:rPr lang="de-DE" dirty="0"/>
+              <a:t> &amp; Schmutz (2018)   </a:t>
+            </a:r>
+            <a:r>
+              <a:rPr lang="de-DE" baseline="30000" dirty="0"/>
+              <a:t>2 </a:t>
+            </a:r>
+            <a:r>
+              <a:rPr lang="de-DE" dirty="0"/>
+              <a:t>Lena &amp; Peterson (2008)   </a:t>
+            </a:r>
+            <a:r>
+              <a:rPr lang="de-DE" baseline="30000" dirty="0"/>
+              <a:t>3 </a:t>
+            </a:r>
+            <a:r>
+              <a:rPr lang="de-DE" dirty="0"/>
+              <a:t>Werner (2023)   </a:t>
+            </a:r>
+            <a:r>
+              <a:rPr lang="de-DE" baseline="30000" dirty="0"/>
+              <a:t>4 </a:t>
+            </a:r>
+            <a:r>
+              <a:rPr lang="de-DE" dirty="0"/>
+              <a:t>Lepa &amp; Radke (2026)</a:t>
+            </a:r>
+          </a:p>
+        </p:txBody>
+      </p:sp>
       <p:pic>
         <p:nvPicPr>
-          <p:cNvPr id="9" name="Grafik 8" descr="Brezel mit einfarbiger Füllung">
+          <p:cNvPr id="5" name="Grafik 4" descr="Sitzungssaal Silhouette">
             <a:extLst>
               <a:ext uri="{FF2B5EF4-FFF2-40B4-BE49-F238E27FC236}">
-                <a16:creationId xmlns:a16="http://schemas.microsoft.com/office/drawing/2014/main" id="{23A33A43-66D7-FD37-1FCE-113E2135D8E5}"/>
+                <a16:creationId xmlns:a16="http://schemas.microsoft.com/office/drawing/2014/main" id="{F6CB3082-A2C4-7D01-169F-62F43E3456AF}"/>
               </a:ext>
             </a:extLst>
           </p:cNvPr>
@@ -15742,112 +16010,7 @@
           <a:blip>
             <a:extLst>
               <a:ext uri="{96DAC541-7B7A-43D3-8B79-37D633B846F1}">
-                <asvg:svgBlip xmlns:asvg="http://schemas.microsoft.com/office/drawing/2016/SVG/main" r:embed="rId4"/>
-              </a:ext>
-            </a:extLst>
-          </a:blip>
-          <a:stretch>
-            <a:fillRect/>
-          </a:stretch>
-        </p:blipFill>
-        <p:spPr>
-          <a:xfrm>
-            <a:off x="8954448" y="706087"/>
-            <a:ext cx="914400" cy="914400"/>
-          </a:xfrm>
-          <a:prstGeom prst="rect">
-            <a:avLst/>
-          </a:prstGeom>
-        </p:spPr>
-      </p:pic>
-      <p:sp>
-        <p:nvSpPr>
-          <p:cNvPr id="3" name="Fußzeilenplatzhalter 2">
-            <a:extLst>
-              <a:ext uri="{FF2B5EF4-FFF2-40B4-BE49-F238E27FC236}">
-                <a16:creationId xmlns:a16="http://schemas.microsoft.com/office/drawing/2014/main" id="{76194510-C1D1-C540-FE2E-A3CD8BDDDA1E}"/>
-              </a:ext>
-            </a:extLst>
-          </p:cNvPr>
-          <p:cNvSpPr>
-            <a:spLocks noGrp="1"/>
-          </p:cNvSpPr>
-          <p:nvPr>
-            <p:ph type="ftr" sz="quarter" idx="11"/>
-          </p:nvPr>
-        </p:nvSpPr>
-        <p:spPr>
-          <a:xfrm>
-            <a:off x="468429" y="6356351"/>
-            <a:ext cx="11292199" cy="365125"/>
-          </a:xfrm>
-        </p:spPr>
-        <p:txBody>
-          <a:bodyPr/>
-          <a:lstStyle/>
-          <a:p>
-            <a:r>
-              <a:rPr lang="de-DE" baseline="30000" dirty="0"/>
-              <a:t>1 </a:t>
-            </a:r>
-            <a:r>
-              <a:rPr lang="de-DE" dirty="0"/>
-              <a:t>van </a:t>
-            </a:r>
-            <a:r>
-              <a:rPr lang="de-DE" dirty="0" err="1"/>
-              <a:t>Venrooj</a:t>
-            </a:r>
-            <a:r>
-              <a:rPr lang="de-DE" dirty="0"/>
-              <a:t> &amp; Schmutz (2018)   </a:t>
-            </a:r>
-            <a:r>
-              <a:rPr lang="de-DE" baseline="30000" dirty="0"/>
-              <a:t>2 </a:t>
-            </a:r>
-            <a:r>
-              <a:rPr lang="de-DE" dirty="0"/>
-              <a:t>Lena &amp; Peterson (2008)   </a:t>
-            </a:r>
-            <a:r>
-              <a:rPr lang="de-DE" baseline="30000" dirty="0"/>
-              <a:t>3 </a:t>
-            </a:r>
-            <a:r>
-              <a:rPr lang="de-DE" dirty="0"/>
-              <a:t>Werner (2023)   </a:t>
-            </a:r>
-            <a:r>
-              <a:rPr lang="de-DE" baseline="30000" dirty="0"/>
-              <a:t>4 </a:t>
-            </a:r>
-            <a:r>
-              <a:rPr lang="de-DE" dirty="0"/>
-              <a:t>Lepa &amp; Radke (2026)</a:t>
-            </a:r>
-          </a:p>
-        </p:txBody>
-      </p:sp>
-      <p:pic>
-        <p:nvPicPr>
-          <p:cNvPr id="5" name="Grafik 4" descr="Sitzungssaal Silhouette">
-            <a:extLst>
-              <a:ext uri="{FF2B5EF4-FFF2-40B4-BE49-F238E27FC236}">
-                <a16:creationId xmlns:a16="http://schemas.microsoft.com/office/drawing/2014/main" id="{F6CB3082-A2C4-7D01-169F-62F43E3456AF}"/>
-              </a:ext>
-            </a:extLst>
-          </p:cNvPr>
-          <p:cNvPicPr>
-            <a:picLocks noChangeAspect="1"/>
-          </p:cNvPicPr>
-          <p:nvPr/>
-        </p:nvPicPr>
-        <p:blipFill>
-          <a:blip>
-            <a:extLst>
-              <a:ext uri="{96DAC541-7B7A-43D3-8B79-37D633B846F1}">
-                <asvg:svgBlip xmlns:asvg="http://schemas.microsoft.com/office/drawing/2016/SVG/main" r:embed="rId5"/>
+                <asvg:svgBlip xmlns:asvg="http://schemas.microsoft.com/office/drawing/2016/SVG/main" r:embed="rId3"/>
               </a:ext>
             </a:extLst>
           </a:blip>
@@ -15883,7 +16046,7 @@
           <a:blip>
             <a:extLst>
               <a:ext uri="{96DAC541-7B7A-43D3-8B79-37D633B846F1}">
-                <asvg:svgBlip xmlns:asvg="http://schemas.microsoft.com/office/drawing/2016/SVG/main" r:embed="rId6"/>
+                <asvg:svgBlip xmlns:asvg="http://schemas.microsoft.com/office/drawing/2016/SVG/main" r:embed="rId4"/>
               </a:ext>
             </a:extLst>
           </a:blip>
@@ -15919,7 +16082,7 @@
           <a:blip>
             <a:extLst>
               <a:ext uri="{96DAC541-7B7A-43D3-8B79-37D633B846F1}">
-                <asvg:svgBlip xmlns:asvg="http://schemas.microsoft.com/office/drawing/2016/SVG/main" r:embed="rId7"/>
+                <asvg:svgBlip xmlns:asvg="http://schemas.microsoft.com/office/drawing/2016/SVG/main" r:embed="rId5"/>
               </a:ext>
             </a:extLst>
           </a:blip>
@@ -15931,6 +16094,78 @@
           <a:xfrm>
             <a:off x="8497248" y="4093452"/>
             <a:ext cx="914400" cy="914400"/>
+          </a:xfrm>
+          <a:prstGeom prst="rect">
+            <a:avLst/>
+          </a:prstGeom>
+        </p:spPr>
+      </p:pic>
+      <p:pic>
+        <p:nvPicPr>
+          <p:cNvPr id="6" name="Grafik 5" descr="Statistiken Silhouette">
+            <a:extLst>
+              <a:ext uri="{FF2B5EF4-FFF2-40B4-BE49-F238E27FC236}">
+                <a16:creationId xmlns:a16="http://schemas.microsoft.com/office/drawing/2014/main" id="{FEBCCDF5-956F-D3D5-83F1-4FDA63EAC0CC}"/>
+              </a:ext>
+            </a:extLst>
+          </p:cNvPr>
+          <p:cNvPicPr>
+            <a:picLocks noChangeAspect="1"/>
+          </p:cNvPicPr>
+          <p:nvPr/>
+        </p:nvPicPr>
+        <p:blipFill>
+          <a:blip>
+            <a:extLst>
+              <a:ext uri="{96DAC541-7B7A-43D3-8B79-37D633B846F1}">
+                <asvg:svgBlip xmlns:asvg="http://schemas.microsoft.com/office/drawing/2016/SVG/main" r:embed="rId6"/>
+              </a:ext>
+            </a:extLst>
+          </a:blip>
+          <a:stretch>
+            <a:fillRect/>
+          </a:stretch>
+        </p:blipFill>
+        <p:spPr>
+          <a:xfrm>
+            <a:off x="8716397" y="815165"/>
+            <a:ext cx="914400" cy="914400"/>
+          </a:xfrm>
+          <a:prstGeom prst="rect">
+            <a:avLst/>
+          </a:prstGeom>
+        </p:spPr>
+      </p:pic>
+      <p:pic>
+        <p:nvPicPr>
+          <p:cNvPr id="14" name="Grafik 13" descr="Uhr mit einfarbiger Füllung">
+            <a:extLst>
+              <a:ext uri="{FF2B5EF4-FFF2-40B4-BE49-F238E27FC236}">
+                <a16:creationId xmlns:a16="http://schemas.microsoft.com/office/drawing/2014/main" id="{5BACDBAA-73CE-F074-09B0-94601BFE136D}"/>
+              </a:ext>
+            </a:extLst>
+          </p:cNvPr>
+          <p:cNvPicPr>
+            <a:picLocks noChangeAspect="1"/>
+          </p:cNvPicPr>
+          <p:nvPr/>
+        </p:nvPicPr>
+        <p:blipFill>
+          <a:blip>
+            <a:extLst>
+              <a:ext uri="{96DAC541-7B7A-43D3-8B79-37D633B846F1}">
+                <asvg:svgBlip xmlns:asvg="http://schemas.microsoft.com/office/drawing/2016/SVG/main" r:embed="rId7"/>
+              </a:ext>
+            </a:extLst>
+          </a:blip>
+          <a:stretch>
+            <a:fillRect/>
+          </a:stretch>
+        </p:blipFill>
+        <p:spPr>
+          <a:xfrm>
+            <a:off x="8046547" y="889011"/>
+            <a:ext cx="766707" cy="766707"/>
           </a:xfrm>
           <a:prstGeom prst="rect">
             <a:avLst/>
@@ -15959,6 +16194,9 @@
                     <p:cTn id="3" fill="hold">
                       <p:stCondLst>
                         <p:cond delay="indefinite"/>
+                        <p:cond evt="onBegin" delay="0">
+                          <p:tn val="2"/>
+                        </p:cond>
                       </p:stCondLst>
                       <p:childTnLst>
                         <p:par>
@@ -15968,7 +16206,7 @@
                             </p:stCondLst>
                             <p:childTnLst>
                               <p:par>
-                                <p:cTn id="5" presetID="1" presetClass="entr" presetSubtype="0" fill="hold" nodeType="clickEffect">
+                                <p:cTn id="5" presetID="1" presetClass="entr" presetSubtype="0" fill="hold" grpId="0" nodeType="withEffect">
                                   <p:stCondLst>
                                     <p:cond delay="0"/>
                                   </p:stCondLst>
@@ -15976,60 +16214,6 @@
                                     <p:set>
                                       <p:cBhvr>
                                         <p:cTn id="6" dur="1" fill="hold">
-                                          <p:stCondLst>
-                                            <p:cond delay="0"/>
-                                          </p:stCondLst>
-                                        </p:cTn>
-                                        <p:tgtEl>
-                                          <p:spTgt spid="8"/>
-                                        </p:tgtEl>
-                                        <p:attrNameLst>
-                                          <p:attrName>style.visibility</p:attrName>
-                                        </p:attrNameLst>
-                                      </p:cBhvr>
-                                      <p:to>
-                                        <p:strVal val="visible"/>
-                                      </p:to>
-                                    </p:set>
-                                  </p:childTnLst>
-                                </p:cTn>
-                              </p:par>
-                              <p:par>
-                                <p:cTn id="7" presetID="1" presetClass="entr" presetSubtype="0" fill="hold" nodeType="withEffect">
-                                  <p:stCondLst>
-                                    <p:cond delay="0"/>
-                                  </p:stCondLst>
-                                  <p:childTnLst>
-                                    <p:set>
-                                      <p:cBhvr>
-                                        <p:cTn id="8" dur="1" fill="hold">
-                                          <p:stCondLst>
-                                            <p:cond delay="0"/>
-                                          </p:stCondLst>
-                                        </p:cTn>
-                                        <p:tgtEl>
-                                          <p:spTgt spid="9"/>
-                                        </p:tgtEl>
-                                        <p:attrNameLst>
-                                          <p:attrName>style.visibility</p:attrName>
-                                        </p:attrNameLst>
-                                      </p:cBhvr>
-                                      <p:to>
-                                        <p:strVal val="visible"/>
-                                      </p:to>
-                                    </p:set>
-                                  </p:childTnLst>
-                                </p:cTn>
-                              </p:par>
-                              <p:par>
-                                <p:cTn id="9" presetID="1" presetClass="entr" presetSubtype="0" fill="hold" grpId="0" nodeType="withEffect">
-                                  <p:stCondLst>
-                                    <p:cond delay="0"/>
-                                  </p:stCondLst>
-                                  <p:childTnLst>
-                                    <p:set>
-                                      <p:cBhvr>
-                                        <p:cTn id="10" dur="1" fill="hold">
                                           <p:stCondLst>
                                             <p:cond delay="0"/>
                                           </p:stCondLst>
@@ -16055,26 +16239,26 @@
                     </p:cTn>
                   </p:par>
                   <p:par>
-                    <p:cTn id="11" fill="hold">
+                    <p:cTn id="7" fill="hold">
                       <p:stCondLst>
                         <p:cond delay="indefinite"/>
                       </p:stCondLst>
                       <p:childTnLst>
                         <p:par>
-                          <p:cTn id="12" fill="hold">
+                          <p:cTn id="8" fill="hold">
                             <p:stCondLst>
                               <p:cond delay="0"/>
                             </p:stCondLst>
                             <p:childTnLst>
                               <p:par>
-                                <p:cTn id="13" presetID="1" presetClass="entr" presetSubtype="0" fill="hold" grpId="0" nodeType="clickEffect">
+                                <p:cTn id="9" presetID="1" presetClass="entr" presetSubtype="0" fill="hold" grpId="0" nodeType="clickEffect">
                                   <p:stCondLst>
                                     <p:cond delay="0"/>
                                   </p:stCondLst>
                                   <p:childTnLst>
                                     <p:set>
                                       <p:cBhvr>
-                                        <p:cTn id="14" dur="1" fill="hold">
+                                        <p:cTn id="10" dur="1" fill="hold">
                                           <p:stCondLst>
                                             <p:cond delay="0"/>
                                           </p:stCondLst>
@@ -16098,14 +16282,14 @@
                                 </p:cTn>
                               </p:par>
                               <p:par>
-                                <p:cTn id="15" presetID="1" presetClass="entr" presetSubtype="0" fill="hold" nodeType="withEffect">
+                                <p:cTn id="11" presetID="1" presetClass="entr" presetSubtype="0" fill="hold" nodeType="withEffect">
                                   <p:stCondLst>
                                     <p:cond delay="0"/>
                                   </p:stCondLst>
                                   <p:childTnLst>
                                     <p:set>
                                       <p:cBhvr>
-                                        <p:cTn id="16" dur="1" fill="hold">
+                                        <p:cTn id="12" dur="1" fill="hold">
                                           <p:stCondLst>
                                             <p:cond delay="0"/>
                                           </p:stCondLst>
@@ -16125,14 +16309,14 @@
                                 </p:cTn>
                               </p:par>
                               <p:par>
-                                <p:cTn id="17" presetID="1" presetClass="entr" presetSubtype="0" fill="hold" grpId="0" nodeType="withEffect">
+                                <p:cTn id="13" presetID="1" presetClass="entr" presetSubtype="0" fill="hold" grpId="0" nodeType="withEffect">
                                   <p:stCondLst>
                                     <p:cond delay="0"/>
                                   </p:stCondLst>
                                   <p:childTnLst>
                                     <p:set>
                                       <p:cBhvr>
-                                        <p:cTn id="18" dur="1" fill="hold">
+                                        <p:cTn id="14" dur="1" fill="hold">
                                           <p:stCondLst>
                                             <p:cond delay="0"/>
                                           </p:stCondLst>
@@ -16158,26 +16342,26 @@
                     </p:cTn>
                   </p:par>
                   <p:par>
-                    <p:cTn id="19" fill="hold">
+                    <p:cTn id="15" fill="hold">
                       <p:stCondLst>
                         <p:cond delay="indefinite"/>
                       </p:stCondLst>
                       <p:childTnLst>
                         <p:par>
-                          <p:cTn id="20" fill="hold">
+                          <p:cTn id="16" fill="hold">
                             <p:stCondLst>
                               <p:cond delay="0"/>
                             </p:stCondLst>
                             <p:childTnLst>
                               <p:par>
-                                <p:cTn id="21" presetID="1" presetClass="entr" presetSubtype="0" fill="hold" nodeType="clickEffect">
+                                <p:cTn id="17" presetID="1" presetClass="entr" presetSubtype="0" fill="hold" nodeType="clickEffect">
                                   <p:stCondLst>
                                     <p:cond delay="0"/>
                                   </p:stCondLst>
                                   <p:childTnLst>
                                     <p:set>
                                       <p:cBhvr>
-                                        <p:cTn id="22" dur="1" fill="hold">
+                                        <p:cTn id="18" dur="1" fill="hold">
                                           <p:stCondLst>
                                             <p:cond delay="0"/>
                                           </p:stCondLst>
@@ -16197,14 +16381,14 @@
                                 </p:cTn>
                               </p:par>
                               <p:par>
-                                <p:cTn id="23" presetID="1" presetClass="entr" presetSubtype="0" fill="hold" grpId="0" nodeType="withEffect">
+                                <p:cTn id="19" presetID="1" presetClass="entr" presetSubtype="0" fill="hold" grpId="0" nodeType="withEffect">
                                   <p:stCondLst>
                                     <p:cond delay="0"/>
                                   </p:stCondLst>
                                   <p:childTnLst>
                                     <p:set>
                                       <p:cBhvr>
-                                        <p:cTn id="24" dur="1" fill="hold">
+                                        <p:cTn id="20" dur="1" fill="hold">
                                           <p:stCondLst>
                                             <p:cond delay="0"/>
                                           </p:stCondLst>
@@ -17620,27 +17804,8 @@
                   </a:schemeClr>
                 </a:solidFill>
               </a:rPr>
-              <a:t>Interpretability and </a:t>
-            </a:r>
-            <a:r>
-              <a:rPr lang="en-US" sz="2200" dirty="0" err="1">
-                <a:solidFill>
-                  <a:schemeClr val="tx1">
-                    <a:lumMod val="50000"/>
-                    <a:lumOff val="50000"/>
-                  </a:schemeClr>
-                </a:solidFill>
-              </a:rPr>
-              <a:t>Transparancy</a:t>
-            </a:r>
-            <a:endParaRPr lang="en-US" sz="2200" dirty="0">
-              <a:solidFill>
-                <a:schemeClr val="tx1">
-                  <a:lumMod val="50000"/>
-                  <a:lumOff val="50000"/>
-                </a:schemeClr>
-              </a:solidFill>
-            </a:endParaRPr>
+              <a:t>Interpretability and Transparency</a:t>
+            </a:r>
           </a:p>
         </p:txBody>
       </p:sp>
@@ -18126,29 +18291,7 @@
                   </a:schemeClr>
                 </a:solidFill>
               </a:rPr>
-              <a:t>Often </a:t>
-            </a:r>
-            <a:r>
-              <a:rPr lang="en-US" sz="2200" b="1" dirty="0" err="1">
-                <a:solidFill>
-                  <a:schemeClr val="tx1">
-                    <a:lumMod val="75000"/>
-                    <a:lumOff val="25000"/>
-                  </a:schemeClr>
-                </a:solidFill>
-              </a:rPr>
-              <a:t>emphazided</a:t>
-            </a:r>
-            <a:r>
-              <a:rPr lang="en-US" sz="2200" b="1" dirty="0">
-                <a:solidFill>
-                  <a:schemeClr val="tx1">
-                    <a:lumMod val="75000"/>
-                    <a:lumOff val="25000"/>
-                  </a:schemeClr>
-                </a:solidFill>
-              </a:rPr>
-              <a:t> interpretable formal structural features</a:t>
+              <a:t>Often emphasized interpretable formal structural features</a:t>
             </a:r>
             <a:r>
               <a:rPr lang="en-US" sz="2200" b="1" baseline="30000" dirty="0">
@@ -18398,7 +18541,7 @@
             </a:r>
             <a:r>
               <a:rPr lang="en-US" dirty="0"/>
-              <a:t>Napier &amp; Shamir (2018) </a:t>
+              <a:t>Napier &amp; Shamir (2018)   </a:t>
             </a:r>
             <a:r>
               <a:rPr lang="en-US" baseline="30000" dirty="0"/>
@@ -18406,7 +18549,7 @@
             </a:r>
             <a:r>
               <a:rPr lang="en-US" dirty="0"/>
-              <a:t>Stoia (2020)  </a:t>
+              <a:t>Stoia (2020)   </a:t>
             </a:r>
             <a:r>
               <a:rPr lang="en-US" baseline="30000" dirty="0"/>
@@ -18414,7 +18557,7 @@
             </a:r>
             <a:r>
               <a:rPr lang="en-US" dirty="0"/>
-              <a:t>Knauf (2025) </a:t>
+              <a:t>Wray &amp; Perkins (2000)   </a:t>
             </a:r>
             <a:r>
               <a:rPr lang="en-US" baseline="30000" dirty="0"/>
@@ -18422,7 +18565,7 @@
             </a:r>
             <a:r>
               <a:rPr lang="en-US" dirty="0"/>
-              <a:t>Wray &amp; Perkins (2000)   </a:t>
+              <a:t>Amin et al. (2021)   </a:t>
             </a:r>
             <a:r>
               <a:rPr lang="en-US" baseline="30000" dirty="0"/>
@@ -18430,7 +18573,7 @@
             </a:r>
             <a:r>
               <a:rPr lang="en-US" dirty="0"/>
-              <a:t>Amin et al. (2021)</a:t>
+              <a:t>Knauf (2025) </a:t>
             </a:r>
             <a:endParaRPr lang="de-DE" dirty="0"/>
           </a:p>
@@ -18472,27 +18615,7 @@
                   </a:schemeClr>
                 </a:solidFill>
               </a:rPr>
-              <a:t>Often </a:t>
-            </a:r>
-            <a:r>
-              <a:rPr lang="en-US" sz="2200" b="1" dirty="0" err="1">
-                <a:solidFill>
-                  <a:schemeClr val="bg1">
-                    <a:lumMod val="75000"/>
-                  </a:schemeClr>
-                </a:solidFill>
-              </a:rPr>
-              <a:t>emphazided</a:t>
-            </a:r>
-            <a:r>
-              <a:rPr lang="en-US" sz="2200" b="1" dirty="0">
-                <a:solidFill>
-                  <a:schemeClr val="bg1">
-                    <a:lumMod val="75000"/>
-                  </a:schemeClr>
-                </a:solidFill>
-              </a:rPr>
-              <a:t> interpretable formal structural features</a:t>
+              <a:t>Often emphasized interpretable formal structural features</a:t>
             </a:r>
             <a:r>
               <a:rPr lang="en-US" sz="2200" b="1" baseline="30000" dirty="0">
@@ -18580,7 +18703,7 @@
         <p:spPr>
           <a:xfrm>
             <a:off x="6287344" y="1484784"/>
-            <a:ext cx="5904656" cy="4493538"/>
+            <a:ext cx="5904656" cy="4832092"/>
           </a:xfrm>
           <a:prstGeom prst="rect">
             <a:avLst/>
@@ -18648,11 +18771,18 @@
             </a:pPr>
             <a:r>
               <a:rPr lang="en-US" sz="2200" dirty="0"/>
-              <a:t>vocalizations</a:t>
+              <a:t>multiword expressions</a:t>
             </a:r>
             <a:r>
               <a:rPr lang="en-US" sz="2200" baseline="30000" dirty="0"/>
-              <a:t>9</a:t>
+              <a:t>9,10,</a:t>
+            </a:r>
+            <a:br>
+              <a:rPr lang="en-US" sz="2200" dirty="0"/>
+            </a:br>
+            <a:r>
+              <a:rPr lang="en-US" sz="2200" dirty="0"/>
+              <a:t>(common collocations, idioms)</a:t>
             </a:r>
           </a:p>
           <a:p>
@@ -18662,18 +18792,18 @@
             </a:pPr>
             <a:r>
               <a:rPr lang="en-US" sz="2200" dirty="0"/>
-              <a:t>multiword expressions</a:t>
+              <a:t>single words</a:t>
             </a:r>
             <a:r>
               <a:rPr lang="en-US" sz="2200" baseline="30000" dirty="0"/>
-              <a:t>10,11</a:t>
+              <a:t>4,5</a:t>
             </a:r>
             <a:br>
               <a:rPr lang="en-US" sz="2200" dirty="0"/>
             </a:br>
             <a:r>
               <a:rPr lang="en-US" sz="2200" dirty="0"/>
-              <a:t>(common collocations, idioms)</a:t>
+              <a:t>(slang, spelling, lexical words)</a:t>
             </a:r>
           </a:p>
           <a:p>
@@ -18683,19 +18813,19 @@
             </a:pPr>
             <a:r>
               <a:rPr lang="en-US" sz="2200" dirty="0"/>
-              <a:t>single words</a:t>
+              <a:t>vocalizations</a:t>
             </a:r>
             <a:r>
               <a:rPr lang="en-US" sz="2200" baseline="30000" dirty="0"/>
-              <a:t>4,5</a:t>
-            </a:r>
-            <a:br>
-              <a:rPr lang="en-US" sz="2200" dirty="0"/>
-            </a:br>
-            <a:r>
-              <a:rPr lang="en-US" sz="2200" dirty="0"/>
-              <a:t>(slang, spelling, lexical words)</a:t>
-            </a:r>
+              <a:t>11</a:t>
+            </a:r>
+          </a:p>
+          <a:p>
+            <a:pPr marL="342900" indent="-342900">
+              <a:buFont typeface="Arial" panose="020B0604020202020204" pitchFamily="34" charset="0"/>
+              <a:buChar char="•"/>
+            </a:pPr>
+            <a:endParaRPr lang="en-US" sz="2200" dirty="0"/>
           </a:p>
           <a:p>
             <a:endParaRPr lang="en-US" sz="2200" dirty="0"/>
@@ -20304,7 +20434,7 @@
                   <a:schemeClr val="tx1"/>
                 </a:solidFill>
               </a:rPr>
-              <a:t>and Release genres from </a:t>
+              <a:t>and release genres from </a:t>
             </a:r>
             <a:r>
               <a:rPr lang="en-US" sz="2000" b="1" i="1" dirty="0">
@@ -20354,7 +20484,7 @@
                   <a:schemeClr val="tx1"/>
                 </a:solidFill>
               </a:rPr>
-              <a:t> assignments (35% remaining) reduced to most specific single-label</a:t>
+              <a:t> assignments (35% remaining) reduced to most specific single genre label</a:t>
             </a:r>
           </a:p>
         </p:txBody>
@@ -21315,7 +21445,15 @@
             </a:pPr>
             <a:r>
               <a:rPr lang="en-US" sz="2000" dirty="0"/>
-              <a:t>normalize “*”</a:t>
+              <a:t>unify “*” (</a:t>
+            </a:r>
+            <a:r>
+              <a:rPr lang="en-US" sz="2000" dirty="0" err="1"/>
+              <a:t>e.g</a:t>
+            </a:r>
+            <a:r>
+              <a:rPr lang="en-US" sz="2000" dirty="0"/>
+              <a:t>, “f*ck” -&gt; “fuck”)</a:t>
             </a:r>
           </a:p>
           <a:p>
@@ -21325,7 +21463,14 @@
             </a:pPr>
             <a:r>
               <a:rPr lang="en-US" sz="2000" dirty="0"/>
-              <a:t>remove structure indicators (e.g., “chorus”)</a:t>
+              <a:t>remove structure indicators </a:t>
+            </a:r>
+            <a:br>
+              <a:rPr lang="en-US" sz="2000" dirty="0"/>
+            </a:br>
+            <a:r>
+              <a:rPr lang="en-US" sz="2000" dirty="0"/>
+              <a:t>(e.g., “chorus”)</a:t>
             </a:r>
           </a:p>
           <a:p>
@@ -21335,7 +21480,7 @@
             </a:pPr>
             <a:r>
               <a:rPr lang="en-US" sz="2000" dirty="0"/>
-              <a:t>fix missing apostrophes</a:t>
+              <a:t>fix missing apostrophes </a:t>
             </a:r>
           </a:p>
         </p:txBody>
@@ -21400,8 +21545,13 @@
             </a:pPr>
             <a:r>
               <a:rPr lang="en-US" sz="2000" dirty="0"/>
-              <a:t>min 2 characters</a:t>
-            </a:r>
+              <a:t>min 3 characters, no </a:t>
+            </a:r>
+            <a:r>
+              <a:rPr lang="en-US" sz="2000" dirty="0" err="1"/>
+              <a:t>stopwords</a:t>
+            </a:r>
+            <a:endParaRPr lang="en-US" sz="2000" dirty="0"/>
           </a:p>
           <a:p>
             <a:pPr marL="174625" indent="-174625">
@@ -21410,7 +21560,7 @@
             </a:pPr>
             <a:r>
               <a:rPr lang="en-US" sz="2000" dirty="0"/>
-              <a:t>must be in English vocabulary of </a:t>
+              <a:t>must be in English vocabulary whitelist  (</a:t>
             </a:r>
             <a:r>
               <a:rPr lang="en-US" sz="2000" i="1" dirty="0" err="1"/>
@@ -21426,7 +21576,7 @@
             </a:r>
             <a:r>
               <a:rPr lang="en-US" sz="2000" dirty="0"/>
-              <a:t> Python libraries</a:t>
+              <a:t> Python libraries)</a:t>
             </a:r>
           </a:p>
         </p:txBody>

</xml_diff>

<commit_message>
correct file paths distilBERT
</commit_message>
<xml_diff>
--- a/reports/current_presentation.pptx
+++ b/reports/current_presentation.pptx
@@ -249,7 +249,7 @@
           <a:p>
             <a:fld id="{AD399400-5849-4723-8898-46BF5BDB3735}" type="datetimeFigureOut">
               <a:rPr lang="en-US" smtClean="0"/>
-              <a:t>4/23/2026</a:t>
+              <a:t>4/24/2026</a:t>
             </a:fld>
             <a:endParaRPr lang="en-US"/>
           </a:p>
@@ -426,7 +426,7 @@
           <a:p>
             <a:fld id="{EC90C3A3-A726-420C-8DD1-C905CEB9E511}" type="datetimeFigureOut">
               <a:rPr lang="de-DE" smtClean="0"/>
-              <a:t>23.04.2026</a:t>
+              <a:t>24.04.2026</a:t>
             </a:fld>
             <a:endParaRPr lang="de-DE"/>
           </a:p>
@@ -3082,7 +3082,7 @@
           <a:p>
             <a:fld id="{33690E58-811E-483E-B740-9C8996AC2956}" type="datetime1">
               <a:rPr lang="de-DE" smtClean="0"/>
-              <a:t>23.04.2026</a:t>
+              <a:t>24.04.2026</a:t>
             </a:fld>
             <a:endParaRPr lang="de-DE"/>
           </a:p>
@@ -3250,7 +3250,7 @@
           <a:p>
             <a:fld id="{C6B6E9B0-EE0C-4B3A-BB69-6CCF46E83C5E}" type="datetime1">
               <a:rPr lang="de-DE" smtClean="0"/>
-              <a:t>23.04.2026</a:t>
+              <a:t>24.04.2026</a:t>
             </a:fld>
             <a:endParaRPr lang="de-DE"/>
           </a:p>
@@ -3428,7 +3428,7 @@
           <a:p>
             <a:fld id="{D8DEB393-392B-487F-B733-C7A016927E97}" type="datetime1">
               <a:rPr lang="de-DE" smtClean="0"/>
-              <a:t>23.04.2026</a:t>
+              <a:t>24.04.2026</a:t>
             </a:fld>
             <a:endParaRPr lang="de-DE"/>
           </a:p>
@@ -3596,7 +3596,7 @@
           <a:p>
             <a:fld id="{BD26C20F-C26F-410B-813C-64F16A8B9B47}" type="datetime1">
               <a:rPr lang="de-DE" smtClean="0"/>
-              <a:t>23.04.2026</a:t>
+              <a:t>24.04.2026</a:t>
             </a:fld>
             <a:endParaRPr lang="de-DE"/>
           </a:p>
@@ -3747,7 +3747,7 @@
           <a:p>
             <a:fld id="{6B9F3A22-DAB4-427F-83FC-348F41F95BAF}" type="datetime1">
               <a:rPr lang="de-DE" smtClean="0"/>
-              <a:t>23.04.2026</a:t>
+              <a:t>24.04.2026</a:t>
             </a:fld>
             <a:endParaRPr lang="de-DE"/>
           </a:p>
@@ -4250,7 +4250,7 @@
           <a:p>
             <a:fld id="{44845DB8-E77B-4FEE-BCA4-D5E2324673A7}" type="datetime1">
               <a:rPr lang="de-DE" smtClean="0"/>
-              <a:t>23.04.2026</a:t>
+              <a:t>24.04.2026</a:t>
             </a:fld>
             <a:endParaRPr lang="de-DE" dirty="0"/>
           </a:p>
@@ -5680,7 +5680,7 @@
           <a:p>
             <a:fld id="{F5AB78C5-963A-4C35-9FD5-A0A0A78C11CD}" type="datetime1">
               <a:rPr lang="de-DE" smtClean="0"/>
-              <a:t>23.04.2026</a:t>
+              <a:t>24.04.2026</a:t>
             </a:fld>
             <a:endParaRPr lang="de-DE"/>
           </a:p>
@@ -5965,7 +5965,7 @@
           <a:p>
             <a:fld id="{C00B4BFD-FCB8-42C5-B688-F88CFAF184EB}" type="datetime1">
               <a:rPr lang="de-DE" smtClean="0"/>
-              <a:t>23.04.2026</a:t>
+              <a:t>24.04.2026</a:t>
             </a:fld>
             <a:endParaRPr lang="de-DE"/>
           </a:p>
@@ -6384,7 +6384,7 @@
           <a:p>
             <a:fld id="{A5F527D4-BA55-4BD4-9E93-88EF3ED4CE3A}" type="datetime1">
               <a:rPr lang="de-DE" smtClean="0"/>
-              <a:t>23.04.2026</a:t>
+              <a:t>24.04.2026</a:t>
             </a:fld>
             <a:endParaRPr lang="de-DE"/>
           </a:p>
@@ -6501,7 +6501,7 @@
           <a:p>
             <a:fld id="{3B3D687F-B0A0-4C9D-B12F-6DD442A29E20}" type="datetime1">
               <a:rPr lang="de-DE" smtClean="0"/>
-              <a:t>23.04.2026</a:t>
+              <a:t>24.04.2026</a:t>
             </a:fld>
             <a:endParaRPr lang="de-DE"/>
           </a:p>
@@ -6596,7 +6596,7 @@
           <a:p>
             <a:fld id="{9DDF7125-8B58-41AD-BA18-3DA1625618A0}" type="datetime1">
               <a:rPr lang="de-DE" smtClean="0"/>
-              <a:t>23.04.2026</a:t>
+              <a:t>24.04.2026</a:t>
             </a:fld>
             <a:endParaRPr lang="de-DE"/>
           </a:p>
@@ -6871,7 +6871,7 @@
           <a:p>
             <a:fld id="{B73404B6-D29A-4D50-A260-F579AF5882EB}" type="datetime1">
               <a:rPr lang="de-DE" smtClean="0"/>
-              <a:t>23.04.2026</a:t>
+              <a:t>24.04.2026</a:t>
             </a:fld>
             <a:endParaRPr lang="de-DE"/>
           </a:p>
@@ -7126,7 +7126,7 @@
           <a:p>
             <a:fld id="{371051C0-CE15-4F99-AEFA-0D2DE64965B9}" type="datetime1">
               <a:rPr lang="de-DE" smtClean="0"/>
-              <a:t>23.04.2026</a:t>
+              <a:t>24.04.2026</a:t>
             </a:fld>
             <a:endParaRPr lang="de-DE"/>
           </a:p>
@@ -7337,7 +7337,7 @@
           <a:p>
             <a:fld id="{9951ED2B-C080-4D4C-96E4-F13916094505}" type="datetime1">
               <a:rPr lang="de-DE" smtClean="0"/>
-              <a:t>23.04.2026</a:t>
+              <a:t>24.04.2026</a:t>
             </a:fld>
             <a:endParaRPr lang="de-DE"/>
           </a:p>
@@ -11105,10 +11105,10 @@
       </p:grpSpPr>
       <p:pic>
         <p:nvPicPr>
-          <p:cNvPr id="9" name="Grafik 8">
+          <p:cNvPr id="6" name="Grafik 5">
             <a:extLst>
               <a:ext uri="{FF2B5EF4-FFF2-40B4-BE49-F238E27FC236}">
-                <a16:creationId xmlns:a16="http://schemas.microsoft.com/office/drawing/2014/main" id="{30488A62-FDCF-C185-A214-BBA26A9D5349}"/>
+                <a16:creationId xmlns:a16="http://schemas.microsoft.com/office/drawing/2014/main" id="{77A2CB55-4898-6CAF-22BC-011B667EDF50}"/>
               </a:ext>
             </a:extLst>
           </p:cNvPr>
@@ -11125,8 +11125,8 @@
         </p:blipFill>
         <p:spPr>
           <a:xfrm>
-            <a:off x="147801" y="1933561"/>
-            <a:ext cx="5927306" cy="3038683"/>
+            <a:off x="56146" y="1926549"/>
+            <a:ext cx="6009224" cy="3069089"/>
           </a:xfrm>
           <a:prstGeom prst="rect">
             <a:avLst/>
@@ -11263,7 +11263,7 @@
                   <a:srgbClr val="C40D20"/>
                 </a:solidFill>
               </a:rPr>
-              <a:t>83,2% </a:t>
+              <a:t>82,2% </a:t>
             </a:r>
             <a:r>
               <a:rPr lang="de-DE" sz="1800" dirty="0" err="1">
@@ -13006,7 +13006,7 @@
             </a:r>
             <a:r>
               <a:rPr lang="de-DE" sz="2000" dirty="0"/>
-              <a:t> 83,2% </a:t>
+              <a:t> 82,2% </a:t>
             </a:r>
             <a:r>
               <a:rPr lang="de-DE" sz="2000" dirty="0" err="1"/>

</xml_diff>